<commit_message>
Diapositivas del seminario final
</commit_message>
<xml_diff>
--- a/RESULTADOS MAYO/DIAPOSITIVAS SEMINARIO 9/PROPUESTA WORKFLOW.pptx
+++ b/RESULTADOS MAYO/DIAPOSITIVAS SEMINARIO 9/PROPUESTA WORKFLOW.pptx
@@ -4,6 +4,9 @@
   <p:sldMasterIdLst>
     <p:sldMasterId id="2147483648" r:id="rId1"/>
   </p:sldMasterIdLst>
+  <p:notesMasterIdLst>
+    <p:notesMasterId r:id="rId6"/>
+  </p:notesMasterIdLst>
   <p:sldIdLst>
     <p:sldId id="256" r:id="rId2"/>
     <p:sldId id="257" r:id="rId3"/>
@@ -113,6 +116,440 @@
     </p:ext>
   </p:extLst>
 </p:presentation>
+</file>
+
+<file path=ppt/notesMasters/notesMaster1.xml><?xml version="1.0" encoding="utf-8"?>
+<p:notesMaster xmlns:a="http://schemas.openxmlformats.org/drawingml/2006/main" xmlns:r="http://schemas.openxmlformats.org/officeDocument/2006/relationships" xmlns:p="http://schemas.openxmlformats.org/presentationml/2006/main">
+  <p:cSld>
+    <p:bg>
+      <p:bgRef idx="1001">
+        <a:schemeClr val="bg1"/>
+      </p:bgRef>
+    </p:bg>
+    <p:spTree>
+      <p:nvGrpSpPr>
+        <p:cNvPr id="1" name=""/>
+        <p:cNvGrpSpPr/>
+        <p:nvPr/>
+      </p:nvGrpSpPr>
+      <p:grpSpPr>
+        <a:xfrm>
+          <a:off x="0" y="0"/>
+          <a:ext cx="0" cy="0"/>
+          <a:chOff x="0" y="0"/>
+          <a:chExt cx="0" cy="0"/>
+        </a:xfrm>
+      </p:grpSpPr>
+      <p:sp>
+        <p:nvSpPr>
+          <p:cNvPr id="2" name="Marcador de encabezado 1"/>
+          <p:cNvSpPr>
+            <a:spLocks noGrp="1"/>
+          </p:cNvSpPr>
+          <p:nvPr>
+            <p:ph type="hdr" sz="quarter"/>
+          </p:nvPr>
+        </p:nvSpPr>
+        <p:spPr>
+          <a:xfrm>
+            <a:off x="0" y="0"/>
+            <a:ext cx="2971800" cy="458788"/>
+          </a:xfrm>
+          <a:prstGeom prst="rect">
+            <a:avLst/>
+          </a:prstGeom>
+        </p:spPr>
+        <p:txBody>
+          <a:bodyPr vert="horz" lIns="91440" tIns="45720" rIns="91440" bIns="45720" rtlCol="0"/>
+          <a:lstStyle>
+            <a:lvl1pPr algn="l">
+              <a:defRPr sz="1200"/>
+            </a:lvl1pPr>
+          </a:lstStyle>
+          <a:p>
+            <a:endParaRPr lang="es-MX"/>
+          </a:p>
+        </p:txBody>
+      </p:sp>
+      <p:sp>
+        <p:nvSpPr>
+          <p:cNvPr id="3" name="Marcador de fecha 2"/>
+          <p:cNvSpPr>
+            <a:spLocks noGrp="1"/>
+          </p:cNvSpPr>
+          <p:nvPr>
+            <p:ph type="dt" idx="1"/>
+          </p:nvPr>
+        </p:nvSpPr>
+        <p:spPr>
+          <a:xfrm>
+            <a:off x="3884613" y="0"/>
+            <a:ext cx="2971800" cy="458788"/>
+          </a:xfrm>
+          <a:prstGeom prst="rect">
+            <a:avLst/>
+          </a:prstGeom>
+        </p:spPr>
+        <p:txBody>
+          <a:bodyPr vert="horz" lIns="91440" tIns="45720" rIns="91440" bIns="45720" rtlCol="0"/>
+          <a:lstStyle>
+            <a:lvl1pPr algn="r">
+              <a:defRPr sz="1200"/>
+            </a:lvl1pPr>
+          </a:lstStyle>
+          <a:p>
+            <a:fld id="{A6C69894-0122-4BA4-91EF-81B470DE8C70}" type="datetimeFigureOut">
+              <a:rPr lang="es-MX" smtClean="0"/>
+              <a:t>26/06/2026</a:t>
+            </a:fld>
+            <a:endParaRPr lang="es-MX"/>
+          </a:p>
+        </p:txBody>
+      </p:sp>
+      <p:sp>
+        <p:nvSpPr>
+          <p:cNvPr id="4" name="Marcador de imagen de diapositiva 3"/>
+          <p:cNvSpPr>
+            <a:spLocks noGrp="1" noRot="1" noChangeAspect="1"/>
+          </p:cNvSpPr>
+          <p:nvPr>
+            <p:ph type="sldImg" idx="2"/>
+          </p:nvPr>
+        </p:nvSpPr>
+        <p:spPr>
+          <a:xfrm>
+            <a:off x="685800" y="1143000"/>
+            <a:ext cx="5486400" cy="3086100"/>
+          </a:xfrm>
+          <a:prstGeom prst="rect">
+            <a:avLst/>
+          </a:prstGeom>
+          <a:noFill/>
+          <a:ln w="12700">
+            <a:solidFill>
+              <a:prstClr val="black"/>
+            </a:solidFill>
+          </a:ln>
+        </p:spPr>
+        <p:txBody>
+          <a:bodyPr vert="horz" lIns="91440" tIns="45720" rIns="91440" bIns="45720" rtlCol="0" anchor="ctr"/>
+          <a:lstStyle/>
+          <a:p>
+            <a:endParaRPr lang="es-MX"/>
+          </a:p>
+        </p:txBody>
+      </p:sp>
+      <p:sp>
+        <p:nvSpPr>
+          <p:cNvPr id="5" name="Marcador de notas 4"/>
+          <p:cNvSpPr>
+            <a:spLocks noGrp="1"/>
+          </p:cNvSpPr>
+          <p:nvPr>
+            <p:ph type="body" sz="quarter" idx="3"/>
+          </p:nvPr>
+        </p:nvSpPr>
+        <p:spPr>
+          <a:xfrm>
+            <a:off x="685800" y="4400550"/>
+            <a:ext cx="5486400" cy="3600450"/>
+          </a:xfrm>
+          <a:prstGeom prst="rect">
+            <a:avLst/>
+          </a:prstGeom>
+        </p:spPr>
+        <p:txBody>
+          <a:bodyPr vert="horz" lIns="91440" tIns="45720" rIns="91440" bIns="45720" rtlCol="0"/>
+          <a:lstStyle/>
+          <a:p>
+            <a:pPr lvl="0"/>
+            <a:r>
+              <a:rPr lang="es-ES"/>
+              <a:t>Haga clic para modificar los estilos de texto del patrón</a:t>
+            </a:r>
+          </a:p>
+          <a:p>
+            <a:pPr lvl="1"/>
+            <a:r>
+              <a:rPr lang="es-ES"/>
+              <a:t>Segundo nivel</a:t>
+            </a:r>
+          </a:p>
+          <a:p>
+            <a:pPr lvl="2"/>
+            <a:r>
+              <a:rPr lang="es-ES"/>
+              <a:t>Tercer nivel</a:t>
+            </a:r>
+          </a:p>
+          <a:p>
+            <a:pPr lvl="3"/>
+            <a:r>
+              <a:rPr lang="es-ES"/>
+              <a:t>Cuarto nivel</a:t>
+            </a:r>
+          </a:p>
+          <a:p>
+            <a:pPr lvl="4"/>
+            <a:r>
+              <a:rPr lang="es-ES"/>
+              <a:t>Quinto nivel</a:t>
+            </a:r>
+            <a:endParaRPr lang="es-MX"/>
+          </a:p>
+        </p:txBody>
+      </p:sp>
+      <p:sp>
+        <p:nvSpPr>
+          <p:cNvPr id="6" name="Marcador de pie de página 5"/>
+          <p:cNvSpPr>
+            <a:spLocks noGrp="1"/>
+          </p:cNvSpPr>
+          <p:nvPr>
+            <p:ph type="ftr" sz="quarter" idx="4"/>
+          </p:nvPr>
+        </p:nvSpPr>
+        <p:spPr>
+          <a:xfrm>
+            <a:off x="0" y="8685213"/>
+            <a:ext cx="2971800" cy="458787"/>
+          </a:xfrm>
+          <a:prstGeom prst="rect">
+            <a:avLst/>
+          </a:prstGeom>
+        </p:spPr>
+        <p:txBody>
+          <a:bodyPr vert="horz" lIns="91440" tIns="45720" rIns="91440" bIns="45720" rtlCol="0" anchor="b"/>
+          <a:lstStyle>
+            <a:lvl1pPr algn="l">
+              <a:defRPr sz="1200"/>
+            </a:lvl1pPr>
+          </a:lstStyle>
+          <a:p>
+            <a:endParaRPr lang="es-MX"/>
+          </a:p>
+        </p:txBody>
+      </p:sp>
+      <p:sp>
+        <p:nvSpPr>
+          <p:cNvPr id="7" name="Marcador de número de diapositiva 6"/>
+          <p:cNvSpPr>
+            <a:spLocks noGrp="1"/>
+          </p:cNvSpPr>
+          <p:nvPr>
+            <p:ph type="sldNum" sz="quarter" idx="5"/>
+          </p:nvPr>
+        </p:nvSpPr>
+        <p:spPr>
+          <a:xfrm>
+            <a:off x="3884613" y="8685213"/>
+            <a:ext cx="2971800" cy="458787"/>
+          </a:xfrm>
+          <a:prstGeom prst="rect">
+            <a:avLst/>
+          </a:prstGeom>
+        </p:spPr>
+        <p:txBody>
+          <a:bodyPr vert="horz" lIns="91440" tIns="45720" rIns="91440" bIns="45720" rtlCol="0" anchor="b"/>
+          <a:lstStyle>
+            <a:lvl1pPr algn="r">
+              <a:defRPr sz="1200"/>
+            </a:lvl1pPr>
+          </a:lstStyle>
+          <a:p>
+            <a:fld id="{6A1F41BE-4118-478A-9E47-A05E2B71DEBE}" type="slidenum">
+              <a:rPr lang="es-MX" smtClean="0"/>
+              <a:t>‹Nº›</a:t>
+            </a:fld>
+            <a:endParaRPr lang="es-MX"/>
+          </a:p>
+        </p:txBody>
+      </p:sp>
+    </p:spTree>
+    <p:extLst>
+      <p:ext uri="{BB962C8B-B14F-4D97-AF65-F5344CB8AC3E}">
+        <p14:creationId xmlns:p14="http://schemas.microsoft.com/office/powerpoint/2010/main" val="2035904361"/>
+      </p:ext>
+    </p:extLst>
+  </p:cSld>
+  <p:clrMap bg1="lt1" tx1="dk1" bg2="lt2" tx2="dk2" accent1="accent1" accent2="accent2" accent3="accent3" accent4="accent4" accent5="accent5" accent6="accent6" hlink="hlink" folHlink="folHlink"/>
+  <p:notesStyle>
+    <a:lvl1pPr marL="0" algn="l" defTabSz="914400" rtl="0" eaLnBrk="1" latinLnBrk="0" hangingPunct="1">
+      <a:defRPr sz="1200" kern="1200">
+        <a:solidFill>
+          <a:schemeClr val="tx1"/>
+        </a:solidFill>
+        <a:latin typeface="+mn-lt"/>
+        <a:ea typeface="+mn-ea"/>
+        <a:cs typeface="+mn-cs"/>
+      </a:defRPr>
+    </a:lvl1pPr>
+    <a:lvl2pPr marL="457200" algn="l" defTabSz="914400" rtl="0" eaLnBrk="1" latinLnBrk="0" hangingPunct="1">
+      <a:defRPr sz="1200" kern="1200">
+        <a:solidFill>
+          <a:schemeClr val="tx1"/>
+        </a:solidFill>
+        <a:latin typeface="+mn-lt"/>
+        <a:ea typeface="+mn-ea"/>
+        <a:cs typeface="+mn-cs"/>
+      </a:defRPr>
+    </a:lvl2pPr>
+    <a:lvl3pPr marL="914400" algn="l" defTabSz="914400" rtl="0" eaLnBrk="1" latinLnBrk="0" hangingPunct="1">
+      <a:defRPr sz="1200" kern="1200">
+        <a:solidFill>
+          <a:schemeClr val="tx1"/>
+        </a:solidFill>
+        <a:latin typeface="+mn-lt"/>
+        <a:ea typeface="+mn-ea"/>
+        <a:cs typeface="+mn-cs"/>
+      </a:defRPr>
+    </a:lvl3pPr>
+    <a:lvl4pPr marL="1371600" algn="l" defTabSz="914400" rtl="0" eaLnBrk="1" latinLnBrk="0" hangingPunct="1">
+      <a:defRPr sz="1200" kern="1200">
+        <a:solidFill>
+          <a:schemeClr val="tx1"/>
+        </a:solidFill>
+        <a:latin typeface="+mn-lt"/>
+        <a:ea typeface="+mn-ea"/>
+        <a:cs typeface="+mn-cs"/>
+      </a:defRPr>
+    </a:lvl4pPr>
+    <a:lvl5pPr marL="1828800" algn="l" defTabSz="914400" rtl="0" eaLnBrk="1" latinLnBrk="0" hangingPunct="1">
+      <a:defRPr sz="1200" kern="1200">
+        <a:solidFill>
+          <a:schemeClr val="tx1"/>
+        </a:solidFill>
+        <a:latin typeface="+mn-lt"/>
+        <a:ea typeface="+mn-ea"/>
+        <a:cs typeface="+mn-cs"/>
+      </a:defRPr>
+    </a:lvl5pPr>
+    <a:lvl6pPr marL="2286000" algn="l" defTabSz="914400" rtl="0" eaLnBrk="1" latinLnBrk="0" hangingPunct="1">
+      <a:defRPr sz="1200" kern="1200">
+        <a:solidFill>
+          <a:schemeClr val="tx1"/>
+        </a:solidFill>
+        <a:latin typeface="+mn-lt"/>
+        <a:ea typeface="+mn-ea"/>
+        <a:cs typeface="+mn-cs"/>
+      </a:defRPr>
+    </a:lvl6pPr>
+    <a:lvl7pPr marL="2743200" algn="l" defTabSz="914400" rtl="0" eaLnBrk="1" latinLnBrk="0" hangingPunct="1">
+      <a:defRPr sz="1200" kern="1200">
+        <a:solidFill>
+          <a:schemeClr val="tx1"/>
+        </a:solidFill>
+        <a:latin typeface="+mn-lt"/>
+        <a:ea typeface="+mn-ea"/>
+        <a:cs typeface="+mn-cs"/>
+      </a:defRPr>
+    </a:lvl7pPr>
+    <a:lvl8pPr marL="3200400" algn="l" defTabSz="914400" rtl="0" eaLnBrk="1" latinLnBrk="0" hangingPunct="1">
+      <a:defRPr sz="1200" kern="1200">
+        <a:solidFill>
+          <a:schemeClr val="tx1"/>
+        </a:solidFill>
+        <a:latin typeface="+mn-lt"/>
+        <a:ea typeface="+mn-ea"/>
+        <a:cs typeface="+mn-cs"/>
+      </a:defRPr>
+    </a:lvl8pPr>
+    <a:lvl9pPr marL="3657600" algn="l" defTabSz="914400" rtl="0" eaLnBrk="1" latinLnBrk="0" hangingPunct="1">
+      <a:defRPr sz="1200" kern="1200">
+        <a:solidFill>
+          <a:schemeClr val="tx1"/>
+        </a:solidFill>
+        <a:latin typeface="+mn-lt"/>
+        <a:ea typeface="+mn-ea"/>
+        <a:cs typeface="+mn-cs"/>
+      </a:defRPr>
+    </a:lvl9pPr>
+  </p:notesStyle>
+</p:notesMaster>
+</file>
+
+<file path=ppt/notesSlides/notesSlide1.xml><?xml version="1.0" encoding="utf-8"?>
+<p:notes xmlns:a="http://schemas.openxmlformats.org/drawingml/2006/main" xmlns:r="http://schemas.openxmlformats.org/officeDocument/2006/relationships" xmlns:p="http://schemas.openxmlformats.org/presentationml/2006/main">
+  <p:cSld>
+    <p:spTree>
+      <p:nvGrpSpPr>
+        <p:cNvPr id="1" name=""/>
+        <p:cNvGrpSpPr/>
+        <p:nvPr/>
+      </p:nvGrpSpPr>
+      <p:grpSpPr>
+        <a:xfrm>
+          <a:off x="0" y="0"/>
+          <a:ext cx="0" cy="0"/>
+          <a:chOff x="0" y="0"/>
+          <a:chExt cx="0" cy="0"/>
+        </a:xfrm>
+      </p:grpSpPr>
+      <p:sp>
+        <p:nvSpPr>
+          <p:cNvPr id="2" name="Marcador de imagen de diapositiva 1"/>
+          <p:cNvSpPr>
+            <a:spLocks noGrp="1" noRot="1" noChangeAspect="1"/>
+          </p:cNvSpPr>
+          <p:nvPr>
+            <p:ph type="sldImg"/>
+          </p:nvPr>
+        </p:nvSpPr>
+        <p:spPr/>
+      </p:sp>
+      <p:sp>
+        <p:nvSpPr>
+          <p:cNvPr id="3" name="Marcador de notas 2"/>
+          <p:cNvSpPr>
+            <a:spLocks noGrp="1"/>
+          </p:cNvSpPr>
+          <p:nvPr>
+            <p:ph type="body" idx="1"/>
+          </p:nvPr>
+        </p:nvSpPr>
+        <p:spPr/>
+        <p:txBody>
+          <a:bodyPr/>
+          <a:lstStyle/>
+          <a:p>
+            <a:endParaRPr lang="es-MX" dirty="0"/>
+          </a:p>
+        </p:txBody>
+      </p:sp>
+      <p:sp>
+        <p:nvSpPr>
+          <p:cNvPr id="4" name="Marcador de número de diapositiva 3"/>
+          <p:cNvSpPr>
+            <a:spLocks noGrp="1"/>
+          </p:cNvSpPr>
+          <p:nvPr>
+            <p:ph type="sldNum" sz="quarter" idx="5"/>
+          </p:nvPr>
+        </p:nvSpPr>
+        <p:spPr/>
+        <p:txBody>
+          <a:bodyPr/>
+          <a:lstStyle/>
+          <a:p>
+            <a:fld id="{6A1F41BE-4118-478A-9E47-A05E2B71DEBE}" type="slidenum">
+              <a:rPr lang="es-MX" smtClean="0"/>
+              <a:t>4</a:t>
+            </a:fld>
+            <a:endParaRPr lang="es-MX"/>
+          </a:p>
+        </p:txBody>
+      </p:sp>
+    </p:spTree>
+    <p:extLst>
+      <p:ext uri="{BB962C8B-B14F-4D97-AF65-F5344CB8AC3E}">
+        <p14:creationId xmlns:p14="http://schemas.microsoft.com/office/powerpoint/2010/main" val="69936303"/>
+      </p:ext>
+    </p:extLst>
+  </p:cSld>
+  <p:clrMapOvr>
+    <a:masterClrMapping/>
+  </p:clrMapOvr>
+</p:notes>
 </file>
 
 <file path=ppt/slideLayouts/slideLayout1.xml><?xml version="1.0" encoding="utf-8"?>
@@ -264,7 +701,7 @@
           <a:p>
             <a:fld id="{A1ECFAA8-8C58-4E04-8B2C-A58AF6FB89F4}" type="datetimeFigureOut">
               <a:rPr lang="es-MX" smtClean="0"/>
-              <a:t>21/06/2026</a:t>
+              <a:t>26/06/2026</a:t>
             </a:fld>
             <a:endParaRPr lang="es-MX"/>
           </a:p>
@@ -464,7 +901,7 @@
           <a:p>
             <a:fld id="{A1ECFAA8-8C58-4E04-8B2C-A58AF6FB89F4}" type="datetimeFigureOut">
               <a:rPr lang="es-MX" smtClean="0"/>
-              <a:t>21/06/2026</a:t>
+              <a:t>26/06/2026</a:t>
             </a:fld>
             <a:endParaRPr lang="es-MX"/>
           </a:p>
@@ -674,7 +1111,7 @@
           <a:p>
             <a:fld id="{A1ECFAA8-8C58-4E04-8B2C-A58AF6FB89F4}" type="datetimeFigureOut">
               <a:rPr lang="es-MX" smtClean="0"/>
-              <a:t>21/06/2026</a:t>
+              <a:t>26/06/2026</a:t>
             </a:fld>
             <a:endParaRPr lang="es-MX"/>
           </a:p>
@@ -874,7 +1311,7 @@
           <a:p>
             <a:fld id="{A1ECFAA8-8C58-4E04-8B2C-A58AF6FB89F4}" type="datetimeFigureOut">
               <a:rPr lang="es-MX" smtClean="0"/>
-              <a:t>21/06/2026</a:t>
+              <a:t>26/06/2026</a:t>
             </a:fld>
             <a:endParaRPr lang="es-MX"/>
           </a:p>
@@ -1150,7 +1587,7 @@
           <a:p>
             <a:fld id="{A1ECFAA8-8C58-4E04-8B2C-A58AF6FB89F4}" type="datetimeFigureOut">
               <a:rPr lang="es-MX" smtClean="0"/>
-              <a:t>21/06/2026</a:t>
+              <a:t>26/06/2026</a:t>
             </a:fld>
             <a:endParaRPr lang="es-MX"/>
           </a:p>
@@ -1418,7 +1855,7 @@
           <a:p>
             <a:fld id="{A1ECFAA8-8C58-4E04-8B2C-A58AF6FB89F4}" type="datetimeFigureOut">
               <a:rPr lang="es-MX" smtClean="0"/>
-              <a:t>21/06/2026</a:t>
+              <a:t>26/06/2026</a:t>
             </a:fld>
             <a:endParaRPr lang="es-MX"/>
           </a:p>
@@ -1833,7 +2270,7 @@
           <a:p>
             <a:fld id="{A1ECFAA8-8C58-4E04-8B2C-A58AF6FB89F4}" type="datetimeFigureOut">
               <a:rPr lang="es-MX" smtClean="0"/>
-              <a:t>21/06/2026</a:t>
+              <a:t>26/06/2026</a:t>
             </a:fld>
             <a:endParaRPr lang="es-MX"/>
           </a:p>
@@ -1975,7 +2412,7 @@
           <a:p>
             <a:fld id="{A1ECFAA8-8C58-4E04-8B2C-A58AF6FB89F4}" type="datetimeFigureOut">
               <a:rPr lang="es-MX" smtClean="0"/>
-              <a:t>21/06/2026</a:t>
+              <a:t>26/06/2026</a:t>
             </a:fld>
             <a:endParaRPr lang="es-MX"/>
           </a:p>
@@ -2088,7 +2525,7 @@
           <a:p>
             <a:fld id="{A1ECFAA8-8C58-4E04-8B2C-A58AF6FB89F4}" type="datetimeFigureOut">
               <a:rPr lang="es-MX" smtClean="0"/>
-              <a:t>21/06/2026</a:t>
+              <a:t>26/06/2026</a:t>
             </a:fld>
             <a:endParaRPr lang="es-MX"/>
           </a:p>
@@ -2401,7 +2838,7 @@
           <a:p>
             <a:fld id="{A1ECFAA8-8C58-4E04-8B2C-A58AF6FB89F4}" type="datetimeFigureOut">
               <a:rPr lang="es-MX" smtClean="0"/>
-              <a:t>21/06/2026</a:t>
+              <a:t>26/06/2026</a:t>
             </a:fld>
             <a:endParaRPr lang="es-MX"/>
           </a:p>
@@ -2690,7 +3127,7 @@
           <a:p>
             <a:fld id="{A1ECFAA8-8C58-4E04-8B2C-A58AF6FB89F4}" type="datetimeFigureOut">
               <a:rPr lang="es-MX" smtClean="0"/>
-              <a:t>21/06/2026</a:t>
+              <a:t>26/06/2026</a:t>
             </a:fld>
             <a:endParaRPr lang="es-MX"/>
           </a:p>
@@ -2933,7 +3370,7 @@
           <a:p>
             <a:fld id="{A1ECFAA8-8C58-4E04-8B2C-A58AF6FB89F4}" type="datetimeFigureOut">
               <a:rPr lang="es-MX" smtClean="0"/>
-              <a:t>21/06/2026</a:t>
+              <a:t>26/06/2026</a:t>
             </a:fld>
             <a:endParaRPr lang="es-MX"/>
           </a:p>
@@ -34483,7 +34920,7 @@
           <a:blip>
             <a:extLst>
               <a:ext uri="{96DAC541-7B7A-43D3-8B79-37D633B846F1}">
-                <asvg:svgBlip xmlns:asvg="http://schemas.microsoft.com/office/drawing/2016/SVG/main" r:embed="rId2"/>
+                <asvg:svgBlip xmlns:asvg="http://schemas.microsoft.com/office/drawing/2016/SVG/main" r:embed="rId3"/>
               </a:ext>
             </a:extLst>
           </a:blip>
@@ -34515,7 +34952,7 @@
         </p:nvSpPr>
         <p:spPr>
           <a:xfrm>
-            <a:off x="1505681" y="725827"/>
+            <a:off x="1541378" y="715221"/>
             <a:ext cx="1110986" cy="646331"/>
           </a:xfrm>
           <a:prstGeom prst="rect">
@@ -34557,7 +34994,7 @@
         <p:spPr>
           <a:xfrm>
             <a:off x="1314595" y="1485028"/>
-            <a:ext cx="0" cy="839363"/>
+            <a:ext cx="0" cy="595818"/>
           </a:xfrm>
           <a:prstGeom prst="straightConnector1">
             <a:avLst/>
@@ -34599,7 +35036,7 @@
           <a:blip>
             <a:extLst>
               <a:ext uri="{96DAC541-7B7A-43D3-8B79-37D633B846F1}">
-                <asvg:svgBlip xmlns:asvg="http://schemas.microsoft.com/office/drawing/2016/SVG/main" r:embed="rId3"/>
+                <asvg:svgBlip xmlns:asvg="http://schemas.microsoft.com/office/drawing/2016/SVG/main" r:embed="rId4"/>
               </a:ext>
             </a:extLst>
           </a:blip>
@@ -34631,8 +35068,8 @@
         </p:nvSpPr>
         <p:spPr>
           <a:xfrm>
-            <a:off x="5558095" y="5385188"/>
-            <a:ext cx="1615909" cy="584775"/>
+            <a:off x="5304095" y="5353438"/>
+            <a:ext cx="1615909" cy="830997"/>
           </a:xfrm>
           <a:prstGeom prst="rect">
             <a:avLst/>
@@ -34647,30 +35084,12 @@
           <a:p>
             <a:pPr algn="ctr"/>
             <a:r>
-              <a:rPr lang="es-MX" sz="1600" dirty="0" err="1">
-                <a:latin typeface="Times New Roman" panose="02020603050405020304" pitchFamily="18" charset="0"/>
-                <a:cs typeface="Times New Roman" panose="02020603050405020304" pitchFamily="18" charset="0"/>
-              </a:rPr>
-              <a:t>Expand</a:t>
-            </a:r>
-            <a:r>
               <a:rPr lang="es-MX" sz="1600" dirty="0">
                 <a:latin typeface="Times New Roman" panose="02020603050405020304" pitchFamily="18" charset="0"/>
                 <a:cs typeface="Times New Roman" panose="02020603050405020304" pitchFamily="18" charset="0"/>
               </a:rPr>
-              <a:t> </a:t>
+              <a:t>Datos expandidos </a:t>
             </a:r>
-            <a:r>
-              <a:rPr lang="es-MX" sz="1600" dirty="0" err="1">
-                <a:latin typeface="Times New Roman" panose="02020603050405020304" pitchFamily="18" charset="0"/>
-                <a:cs typeface="Times New Roman" panose="02020603050405020304" pitchFamily="18" charset="0"/>
-              </a:rPr>
-              <a:t>Dataset</a:t>
-            </a:r>
-            <a:endParaRPr lang="es-MX" sz="1600" dirty="0">
-              <a:latin typeface="Times New Roman" panose="02020603050405020304" pitchFamily="18" charset="0"/>
-              <a:cs typeface="Times New Roman" panose="02020603050405020304" pitchFamily="18" charset="0"/>
-            </a:endParaRPr>
           </a:p>
           <a:p>
             <a:pPr algn="ctr"/>
@@ -34679,21 +35098,7 @@
                 <a:latin typeface="Times New Roman" panose="02020603050405020304" pitchFamily="18" charset="0"/>
                 <a:cs typeface="Times New Roman" panose="02020603050405020304" pitchFamily="18" charset="0"/>
               </a:rPr>
-              <a:t>(Pol </a:t>
-            </a:r>
-            <a:r>
-              <a:rPr lang="es-MX" sz="1600" dirty="0" err="1">
-                <a:latin typeface="Times New Roman" panose="02020603050405020304" pitchFamily="18" charset="0"/>
-                <a:cs typeface="Times New Roman" panose="02020603050405020304" pitchFamily="18" charset="0"/>
-              </a:rPr>
-              <a:t>degree</a:t>
-            </a:r>
-            <a:r>
-              <a:rPr lang="es-MX" sz="1600" dirty="0">
-                <a:latin typeface="Times New Roman" panose="02020603050405020304" pitchFamily="18" charset="0"/>
-                <a:cs typeface="Times New Roman" panose="02020603050405020304" pitchFamily="18" charset="0"/>
-              </a:rPr>
-              <a:t> 2 )</a:t>
+              <a:t>(Pol 2)</a:t>
             </a:r>
           </a:p>
         </p:txBody>
@@ -34710,10 +35115,16 @@
           <p:cNvGraphicFramePr>
             <a:graphicFrameLocks noGrp="1"/>
           </p:cNvGraphicFramePr>
-          <p:nvPr/>
+          <p:nvPr>
+            <p:extLst>
+              <p:ext uri="{D42A27DB-BD31-4B8C-83A1-F6EECF244321}">
+                <p14:modId xmlns:p14="http://schemas.microsoft.com/office/powerpoint/2010/main" val="2090204948"/>
+              </p:ext>
+            </p:extLst>
+          </p:nvPr>
         </p:nvGraphicFramePr>
         <p:xfrm>
-          <a:off x="590695" y="2801980"/>
+          <a:off x="590695" y="2702331"/>
           <a:ext cx="1447800" cy="196850"/>
         </p:xfrm>
         <a:graphic>
@@ -35090,10 +35501,16 @@
           <p:cNvGraphicFramePr>
             <a:graphicFrameLocks noGrp="1"/>
           </p:cNvGraphicFramePr>
-          <p:nvPr/>
+          <p:nvPr>
+            <p:extLst>
+              <p:ext uri="{D42A27DB-BD31-4B8C-83A1-F6EECF244321}">
+                <p14:modId xmlns:p14="http://schemas.microsoft.com/office/powerpoint/2010/main" val="2207392708"/>
+              </p:ext>
+            </p:extLst>
+          </p:nvPr>
         </p:nvGraphicFramePr>
         <p:xfrm>
-          <a:off x="590695" y="3085028"/>
+          <a:off x="590695" y="2985379"/>
           <a:ext cx="1447800" cy="196850"/>
         </p:xfrm>
         <a:graphic>
@@ -35470,10 +35887,16 @@
           <p:cNvGraphicFramePr>
             <a:graphicFrameLocks noGrp="1"/>
           </p:cNvGraphicFramePr>
-          <p:nvPr/>
+          <p:nvPr>
+            <p:extLst>
+              <p:ext uri="{D42A27DB-BD31-4B8C-83A1-F6EECF244321}">
+                <p14:modId xmlns:p14="http://schemas.microsoft.com/office/powerpoint/2010/main" val="602459224"/>
+              </p:ext>
+            </p:extLst>
+          </p:nvPr>
         </p:nvGraphicFramePr>
         <p:xfrm>
-          <a:off x="590695" y="3368076"/>
+          <a:off x="590695" y="3268427"/>
           <a:ext cx="1447800" cy="196850"/>
         </p:xfrm>
         <a:graphic>
@@ -35852,8 +36275,8 @@
         </p:nvSpPr>
         <p:spPr>
           <a:xfrm>
-            <a:off x="825984" y="2208534"/>
-            <a:ext cx="977221" cy="646331"/>
+            <a:off x="115824" y="2039865"/>
+            <a:ext cx="2551571" cy="646331"/>
           </a:xfrm>
           <a:prstGeom prst="rect">
             <a:avLst/>
@@ -35872,21 +36295,17 @@
                 <a:latin typeface="Times New Roman" panose="02020603050405020304" pitchFamily="18" charset="0"/>
                 <a:cs typeface="Times New Roman" panose="02020603050405020304" pitchFamily="18" charset="0"/>
               </a:rPr>
-              <a:t>Start </a:t>
+              <a:t>Fase 1:</a:t>
             </a:r>
-            <a:r>
-              <a:rPr lang="es-MX" dirty="0" err="1">
-                <a:latin typeface="Times New Roman" panose="02020603050405020304" pitchFamily="18" charset="0"/>
-                <a:cs typeface="Times New Roman" panose="02020603050405020304" pitchFamily="18" charset="0"/>
-              </a:rPr>
-              <a:t>Phase</a:t>
-            </a:r>
+          </a:p>
+          <a:p>
+            <a:pPr algn="ctr"/>
             <a:r>
               <a:rPr lang="es-MX" dirty="0">
                 <a:latin typeface="Times New Roman" panose="02020603050405020304" pitchFamily="18" charset="0"/>
                 <a:cs typeface="Times New Roman" panose="02020603050405020304" pitchFamily="18" charset="0"/>
               </a:rPr>
-              <a:t> 1</a:t>
+              <a:t>Selección de variables</a:t>
             </a:r>
           </a:p>
         </p:txBody>
@@ -35907,7 +36326,7 @@
         </p:nvCxnSpPr>
         <p:spPr>
           <a:xfrm>
-            <a:off x="1300635" y="3667810"/>
+            <a:off x="1300635" y="3515408"/>
             <a:ext cx="0" cy="839363"/>
           </a:xfrm>
           <a:prstGeom prst="straightConnector1">
@@ -35946,8 +36365,8 @@
         </p:nvSpPr>
         <p:spPr>
           <a:xfrm>
-            <a:off x="223366" y="4591348"/>
-            <a:ext cx="2425018" cy="369332"/>
+            <a:off x="100267" y="4239646"/>
+            <a:ext cx="2425018" cy="646331"/>
           </a:xfrm>
           <a:prstGeom prst="rect">
             <a:avLst/>
@@ -35962,44 +36381,12 @@
           <a:p>
             <a:pPr algn="ctr"/>
             <a:r>
-              <a:rPr lang="es-MX" dirty="0" err="1">
-                <a:latin typeface="Times New Roman" panose="02020603050405020304" pitchFamily="18" charset="0"/>
-                <a:cs typeface="Times New Roman" panose="02020603050405020304" pitchFamily="18" charset="0"/>
-              </a:rPr>
-              <a:t>Evaluate</a:t>
-            </a:r>
-            <a:r>
               <a:rPr lang="es-MX" dirty="0">
                 <a:latin typeface="Times New Roman" panose="02020603050405020304" pitchFamily="18" charset="0"/>
                 <a:cs typeface="Times New Roman" panose="02020603050405020304" pitchFamily="18" charset="0"/>
               </a:rPr>
-              <a:t> </a:t>
+              <a:t>Expandir y evaluar cada subconjunto</a:t>
             </a:r>
-            <a:r>
-              <a:rPr lang="es-MX" dirty="0" err="1">
-                <a:latin typeface="Times New Roman" panose="02020603050405020304" pitchFamily="18" charset="0"/>
-                <a:cs typeface="Times New Roman" panose="02020603050405020304" pitchFamily="18" charset="0"/>
-              </a:rPr>
-              <a:t>each</a:t>
-            </a:r>
-            <a:r>
-              <a:rPr lang="es-MX" dirty="0">
-                <a:latin typeface="Times New Roman" panose="02020603050405020304" pitchFamily="18" charset="0"/>
-                <a:cs typeface="Times New Roman" panose="02020603050405020304" pitchFamily="18" charset="0"/>
-              </a:rPr>
-              <a:t> </a:t>
-            </a:r>
-            <a:r>
-              <a:rPr lang="es-MX" dirty="0" err="1">
-                <a:latin typeface="Times New Roman" panose="02020603050405020304" pitchFamily="18" charset="0"/>
-                <a:cs typeface="Times New Roman" panose="02020603050405020304" pitchFamily="18" charset="0"/>
-              </a:rPr>
-              <a:t>subset</a:t>
-            </a:r>
-            <a:endParaRPr lang="es-MX" dirty="0">
-              <a:latin typeface="Times New Roman" panose="02020603050405020304" pitchFamily="18" charset="0"/>
-              <a:cs typeface="Times New Roman" panose="02020603050405020304" pitchFamily="18" charset="0"/>
-            </a:endParaRPr>
           </a:p>
         </p:txBody>
       </p:sp>
@@ -36015,10 +36402,16 @@
           <p:cNvGraphicFramePr>
             <a:graphicFrameLocks noGrp="1"/>
           </p:cNvGraphicFramePr>
-          <p:nvPr/>
+          <p:nvPr>
+            <p:extLst>
+              <p:ext uri="{D42A27DB-BD31-4B8C-83A1-F6EECF244321}">
+                <p14:modId xmlns:p14="http://schemas.microsoft.com/office/powerpoint/2010/main" val="594123888"/>
+              </p:ext>
+            </p:extLst>
+          </p:nvPr>
         </p:nvGraphicFramePr>
         <p:xfrm>
-          <a:off x="576735" y="5533595"/>
+          <a:off x="641214" y="5533595"/>
           <a:ext cx="1447800" cy="196850"/>
         </p:xfrm>
         <a:graphic>
@@ -36395,10 +36788,16 @@
           <p:cNvGraphicFramePr>
             <a:graphicFrameLocks noGrp="1"/>
           </p:cNvGraphicFramePr>
-          <p:nvPr/>
+          <p:nvPr>
+            <p:extLst>
+              <p:ext uri="{D42A27DB-BD31-4B8C-83A1-F6EECF244321}">
+                <p14:modId xmlns:p14="http://schemas.microsoft.com/office/powerpoint/2010/main" val="1389144600"/>
+              </p:ext>
+            </p:extLst>
+          </p:nvPr>
         </p:nvGraphicFramePr>
         <p:xfrm>
-          <a:off x="576735" y="5009849"/>
+          <a:off x="641214" y="5009849"/>
           <a:ext cx="1447800" cy="196850"/>
         </p:xfrm>
         <a:graphic>
@@ -36775,10 +37174,16 @@
           <p:cNvGraphicFramePr>
             <a:graphicFrameLocks noGrp="1"/>
           </p:cNvGraphicFramePr>
-          <p:nvPr/>
+          <p:nvPr>
+            <p:extLst>
+              <p:ext uri="{D42A27DB-BD31-4B8C-83A1-F6EECF244321}">
+                <p14:modId xmlns:p14="http://schemas.microsoft.com/office/powerpoint/2010/main" val="4142727697"/>
+              </p:ext>
+            </p:extLst>
+          </p:nvPr>
         </p:nvGraphicFramePr>
         <p:xfrm>
-          <a:off x="576735" y="5274547"/>
+          <a:off x="641214" y="5274547"/>
           <a:ext cx="1447800" cy="196850"/>
         </p:xfrm>
         <a:graphic>
@@ -37157,8 +37562,8 @@
         </p:nvSpPr>
         <p:spPr>
           <a:xfrm>
-            <a:off x="1863700" y="4938795"/>
-            <a:ext cx="977221" cy="830997"/>
+            <a:off x="9822411" y="4417030"/>
+            <a:ext cx="883977" cy="830997"/>
           </a:xfrm>
           <a:prstGeom prst="rect">
             <a:avLst/>
@@ -37173,198 +37578,114 @@
           <a:p>
             <a:pPr algn="ctr"/>
             <a:r>
-              <a:rPr lang="es-MX" sz="1600" dirty="0" err="1">
+              <a:rPr lang="es-MX" sz="1600" dirty="0">
                 <a:latin typeface="Times New Roman" panose="02020603050405020304" pitchFamily="18" charset="0"/>
                 <a:cs typeface="Times New Roman" panose="02020603050405020304" pitchFamily="18" charset="0"/>
               </a:rPr>
-              <a:t>Acc</a:t>
+              <a:t>Fit2(%)</a:t>
             </a:r>
+          </a:p>
+          <a:p>
+            <a:pPr algn="ctr"/>
             <a:r>
               <a:rPr lang="es-MX" sz="1600" dirty="0">
                 <a:latin typeface="Times New Roman" panose="02020603050405020304" pitchFamily="18" charset="0"/>
                 <a:cs typeface="Times New Roman" panose="02020603050405020304" pitchFamily="18" charset="0"/>
               </a:rPr>
-              <a:t>%</a:t>
+              <a:t>Fit2(%)</a:t>
             </a:r>
-            <a:br>
-              <a:rPr lang="es-MX" sz="1600" dirty="0">
-                <a:latin typeface="Times New Roman" panose="02020603050405020304" pitchFamily="18" charset="0"/>
-                <a:cs typeface="Times New Roman" panose="02020603050405020304" pitchFamily="18" charset="0"/>
-              </a:rPr>
-            </a:br>
-            <a:r>
-              <a:rPr lang="es-MX" sz="1600" dirty="0" err="1">
-                <a:latin typeface="Times New Roman" panose="02020603050405020304" pitchFamily="18" charset="0"/>
-                <a:cs typeface="Times New Roman" panose="02020603050405020304" pitchFamily="18" charset="0"/>
-              </a:rPr>
-              <a:t>Acc</a:t>
-            </a:r>
+          </a:p>
+          <a:p>
+            <a:pPr algn="ctr"/>
             <a:r>
               <a:rPr lang="es-MX" sz="1600" dirty="0">
                 <a:latin typeface="Times New Roman" panose="02020603050405020304" pitchFamily="18" charset="0"/>
                 <a:cs typeface="Times New Roman" panose="02020603050405020304" pitchFamily="18" charset="0"/>
               </a:rPr>
-              <a:t>%</a:t>
-            </a:r>
-            <a:br>
-              <a:rPr lang="es-MX" sz="1600" dirty="0">
-                <a:latin typeface="Times New Roman" panose="02020603050405020304" pitchFamily="18" charset="0"/>
-                <a:cs typeface="Times New Roman" panose="02020603050405020304" pitchFamily="18" charset="0"/>
-              </a:rPr>
-            </a:br>
-            <a:r>
-              <a:rPr lang="es-MX" sz="1600" dirty="0" err="1">
-                <a:latin typeface="Times New Roman" panose="02020603050405020304" pitchFamily="18" charset="0"/>
-                <a:cs typeface="Times New Roman" panose="02020603050405020304" pitchFamily="18" charset="0"/>
-              </a:rPr>
-              <a:t>Acc</a:t>
-            </a:r>
-            <a:r>
-              <a:rPr lang="es-MX" sz="1600" dirty="0">
-                <a:latin typeface="Times New Roman" panose="02020603050405020304" pitchFamily="18" charset="0"/>
-                <a:cs typeface="Times New Roman" panose="02020603050405020304" pitchFamily="18" charset="0"/>
-              </a:rPr>
-              <a:t>%</a:t>
+              <a:t>Fit2(%)</a:t>
             </a:r>
           </a:p>
         </p:txBody>
       </p:sp>
-      <p:grpSp>
-        <p:nvGrpSpPr>
-          <p:cNvPr id="58" name="Grupo 57">
+      <p:cxnSp>
+        <p:nvCxnSpPr>
+          <p:cNvPr id="40" name="Conector recto 39">
             <a:extLst>
               <a:ext uri="{FF2B5EF4-FFF2-40B4-BE49-F238E27FC236}">
-                <a16:creationId xmlns:a16="http://schemas.microsoft.com/office/drawing/2014/main" id="{AC7B780A-2524-4595-BF81-A901A063168E}"/>
+                <a16:creationId xmlns:a16="http://schemas.microsoft.com/office/drawing/2014/main" id="{4B6AF184-8CE2-BD32-D27E-B51868C0CD05}"/>
               </a:ext>
             </a:extLst>
           </p:cNvPr>
-          <p:cNvGrpSpPr/>
+          <p:cNvCxnSpPr>
+            <a:cxnSpLocks/>
+          </p:cNvCxnSpPr>
           <p:nvPr/>
-        </p:nvGrpSpPr>
-        <p:grpSpPr>
+        </p:nvCxnSpPr>
+        <p:spPr>
+          <a:xfrm flipV="1">
+            <a:off x="2853835" y="830637"/>
+            <a:ext cx="0" cy="4612135"/>
+          </a:xfrm>
+          <a:prstGeom prst="line">
+            <a:avLst/>
+          </a:prstGeom>
+        </p:spPr>
+        <p:style>
+          <a:lnRef idx="3">
+            <a:schemeClr val="dk1"/>
+          </a:lnRef>
+          <a:fillRef idx="0">
+            <a:schemeClr val="dk1"/>
+          </a:fillRef>
+          <a:effectRef idx="2">
+            <a:schemeClr val="dk1"/>
+          </a:effectRef>
+          <a:fontRef idx="minor">
+            <a:schemeClr val="tx1"/>
+          </a:fontRef>
+        </p:style>
+      </p:cxnSp>
+      <p:cxnSp>
+        <p:nvCxnSpPr>
+          <p:cNvPr id="43" name="Conector recto de flecha 42">
+            <a:extLst>
+              <a:ext uri="{FF2B5EF4-FFF2-40B4-BE49-F238E27FC236}">
+                <a16:creationId xmlns:a16="http://schemas.microsoft.com/office/drawing/2014/main" id="{D06735C2-F034-4376-3835-293D135D1CED}"/>
+              </a:ext>
+            </a:extLst>
+          </p:cNvPr>
+          <p:cNvCxnSpPr>
+            <a:cxnSpLocks/>
+          </p:cNvCxnSpPr>
+          <p:nvPr/>
+        </p:nvCxnSpPr>
+        <p:spPr>
           <a:xfrm>
-            <a:off x="2568702" y="830637"/>
-            <a:ext cx="803135" cy="4612135"/>
-            <a:chOff x="2840921" y="760837"/>
-            <a:chExt cx="1340190" cy="4612135"/>
+            <a:off x="2859693" y="830637"/>
+            <a:ext cx="252181" cy="0"/>
           </a:xfrm>
-        </p:grpSpPr>
-        <p:cxnSp>
-          <p:nvCxnSpPr>
-            <p:cNvPr id="38" name="Conector recto 37">
-              <a:extLst>
-                <a:ext uri="{FF2B5EF4-FFF2-40B4-BE49-F238E27FC236}">
-                  <a16:creationId xmlns:a16="http://schemas.microsoft.com/office/drawing/2014/main" id="{4512C592-7A03-0459-35DD-6E8EB1CF1CF7}"/>
-                </a:ext>
-              </a:extLst>
-            </p:cNvPr>
-            <p:cNvCxnSpPr>
-              <a:stCxn id="32" idx="3"/>
-            </p:cNvCxnSpPr>
-            <p:nvPr/>
-          </p:nvCxnSpPr>
-          <p:spPr>
-            <a:xfrm flipV="1">
-              <a:off x="2840921" y="5354292"/>
-              <a:ext cx="720000" cy="0"/>
-            </a:xfrm>
-            <a:prstGeom prst="line">
-              <a:avLst/>
-            </a:prstGeom>
-          </p:spPr>
-          <p:style>
-            <a:lnRef idx="3">
-              <a:schemeClr val="dk1"/>
-            </a:lnRef>
-            <a:fillRef idx="0">
-              <a:schemeClr val="dk1"/>
-            </a:fillRef>
-            <a:effectRef idx="2">
-              <a:schemeClr val="dk1"/>
-            </a:effectRef>
-            <a:fontRef idx="minor">
-              <a:schemeClr val="tx1"/>
-            </a:fontRef>
-          </p:style>
-        </p:cxnSp>
-        <p:cxnSp>
-          <p:nvCxnSpPr>
-            <p:cNvPr id="40" name="Conector recto 39">
-              <a:extLst>
-                <a:ext uri="{FF2B5EF4-FFF2-40B4-BE49-F238E27FC236}">
-                  <a16:creationId xmlns:a16="http://schemas.microsoft.com/office/drawing/2014/main" id="{4B6AF184-8CE2-BD32-D27E-B51868C0CD05}"/>
-                </a:ext>
-              </a:extLst>
-            </p:cNvPr>
-            <p:cNvCxnSpPr>
-              <a:cxnSpLocks/>
-            </p:cNvCxnSpPr>
-            <p:nvPr/>
-          </p:nvCxnSpPr>
-          <p:spPr>
-            <a:xfrm flipV="1">
-              <a:off x="3580818" y="760837"/>
-              <a:ext cx="0" cy="4612135"/>
-            </a:xfrm>
-            <a:prstGeom prst="line">
-              <a:avLst/>
-            </a:prstGeom>
-          </p:spPr>
-          <p:style>
-            <a:lnRef idx="3">
-              <a:schemeClr val="dk1"/>
-            </a:lnRef>
-            <a:fillRef idx="0">
-              <a:schemeClr val="dk1"/>
-            </a:fillRef>
-            <a:effectRef idx="2">
-              <a:schemeClr val="dk1"/>
-            </a:effectRef>
-            <a:fontRef idx="minor">
-              <a:schemeClr val="tx1"/>
-            </a:fontRef>
-          </p:style>
-        </p:cxnSp>
-        <p:cxnSp>
-          <p:nvCxnSpPr>
-            <p:cNvPr id="43" name="Conector recto de flecha 42">
-              <a:extLst>
-                <a:ext uri="{FF2B5EF4-FFF2-40B4-BE49-F238E27FC236}">
-                  <a16:creationId xmlns:a16="http://schemas.microsoft.com/office/drawing/2014/main" id="{D06735C2-F034-4376-3835-293D135D1CED}"/>
-                </a:ext>
-              </a:extLst>
-            </p:cNvPr>
-            <p:cNvCxnSpPr/>
-            <p:nvPr/>
-          </p:nvCxnSpPr>
-          <p:spPr>
-            <a:xfrm>
-              <a:off x="3580818" y="760837"/>
-              <a:ext cx="600293" cy="0"/>
-            </a:xfrm>
-            <a:prstGeom prst="straightConnector1">
-              <a:avLst/>
-            </a:prstGeom>
-            <a:ln>
-              <a:tailEnd type="triangle"/>
-            </a:ln>
-          </p:spPr>
-          <p:style>
-            <a:lnRef idx="3">
-              <a:schemeClr val="dk1"/>
-            </a:lnRef>
-            <a:fillRef idx="0">
-              <a:schemeClr val="dk1"/>
-            </a:fillRef>
-            <a:effectRef idx="2">
-              <a:schemeClr val="dk1"/>
-            </a:effectRef>
-            <a:fontRef idx="minor">
-              <a:schemeClr val="tx1"/>
-            </a:fontRef>
-          </p:style>
-        </p:cxnSp>
-      </p:grpSp>
+          <a:prstGeom prst="straightConnector1">
+            <a:avLst/>
+          </a:prstGeom>
+          <a:ln>
+            <a:tailEnd type="triangle"/>
+          </a:ln>
+        </p:spPr>
+        <p:style>
+          <a:lnRef idx="3">
+            <a:schemeClr val="dk1"/>
+          </a:lnRef>
+          <a:fillRef idx="0">
+            <a:schemeClr val="dk1"/>
+          </a:fillRef>
+          <a:effectRef idx="2">
+            <a:schemeClr val="dk1"/>
+          </a:effectRef>
+          <a:fontRef idx="minor">
+            <a:schemeClr val="tx1"/>
+          </a:fontRef>
+        </p:style>
+      </p:cxnSp>
       <p:graphicFrame>
         <p:nvGraphicFramePr>
           <p:cNvPr id="46" name="Tabla 45">
@@ -37377,10 +37698,16 @@
           <p:cNvGraphicFramePr>
             <a:graphicFrameLocks noGrp="1"/>
           </p:cNvGraphicFramePr>
-          <p:nvPr/>
+          <p:nvPr>
+            <p:extLst>
+              <p:ext uri="{D42A27DB-BD31-4B8C-83A1-F6EECF244321}">
+                <p14:modId xmlns:p14="http://schemas.microsoft.com/office/powerpoint/2010/main" val="59217389"/>
+              </p:ext>
+            </p:extLst>
+          </p:nvPr>
         </p:nvGraphicFramePr>
         <p:xfrm>
-          <a:off x="4072635" y="1027827"/>
+          <a:off x="4096565" y="1027827"/>
           <a:ext cx="1447800" cy="196850"/>
         </p:xfrm>
         <a:graphic>
@@ -37757,10 +38084,16 @@
           <p:cNvGraphicFramePr>
             <a:graphicFrameLocks noGrp="1"/>
           </p:cNvGraphicFramePr>
-          <p:nvPr/>
+          <p:nvPr>
+            <p:extLst>
+              <p:ext uri="{D42A27DB-BD31-4B8C-83A1-F6EECF244321}">
+                <p14:modId xmlns:p14="http://schemas.microsoft.com/office/powerpoint/2010/main" val="3941001807"/>
+              </p:ext>
+            </p:extLst>
+          </p:nvPr>
         </p:nvGraphicFramePr>
         <p:xfrm>
-          <a:off x="4072635" y="760837"/>
+          <a:off x="4096565" y="760837"/>
           <a:ext cx="1447800" cy="196850"/>
         </p:xfrm>
         <a:graphic>
@@ -38137,10 +38470,16 @@
           <p:cNvGraphicFramePr>
             <a:graphicFrameLocks noGrp="1"/>
           </p:cNvGraphicFramePr>
-          <p:nvPr/>
+          <p:nvPr>
+            <p:extLst>
+              <p:ext uri="{D42A27DB-BD31-4B8C-83A1-F6EECF244321}">
+                <p14:modId xmlns:p14="http://schemas.microsoft.com/office/powerpoint/2010/main" val="95131865"/>
+              </p:ext>
+            </p:extLst>
+          </p:nvPr>
         </p:nvGraphicFramePr>
         <p:xfrm>
-          <a:off x="4070049" y="1294817"/>
+          <a:off x="4093979" y="1294817"/>
           <a:ext cx="1447800" cy="196850"/>
         </p:xfrm>
         <a:graphic>
@@ -38194,7 +38533,7 @@
                         <a:buNone/>
                       </a:pPr>
                       <a:r>
-                        <a:rPr lang="es-MX" sz="1100" b="0" i="0" u="none" strike="noStrike">
+                        <a:rPr lang="es-MX" sz="1100" b="0" i="0" u="none" strike="noStrike" dirty="0">
                           <a:solidFill>
                             <a:srgbClr val="83E28E"/>
                           </a:solidFill>
@@ -38507,92 +38846,6 @@
       </p:graphicFrame>
       <p:sp>
         <p:nvSpPr>
-          <p:cNvPr id="55" name="CuadroTexto 54">
-            <a:extLst>
-              <a:ext uri="{FF2B5EF4-FFF2-40B4-BE49-F238E27FC236}">
-                <a16:creationId xmlns:a16="http://schemas.microsoft.com/office/drawing/2014/main" id="{3EA6C535-F833-138D-A8E9-5D78FA50D051}"/>
-              </a:ext>
-            </a:extLst>
-          </p:cNvPr>
-          <p:cNvSpPr txBox="1"/>
-          <p:nvPr/>
-        </p:nvSpPr>
-        <p:spPr>
-          <a:xfrm>
-            <a:off x="5483207" y="691240"/>
-            <a:ext cx="977221" cy="830997"/>
-          </a:xfrm>
-          <a:prstGeom prst="rect">
-            <a:avLst/>
-          </a:prstGeom>
-          <a:noFill/>
-        </p:spPr>
-        <p:txBody>
-          <a:bodyPr wrap="square" rtlCol="0">
-            <a:spAutoFit/>
-          </a:bodyPr>
-          <a:lstStyle/>
-          <a:p>
-            <a:pPr algn="ctr"/>
-            <a:r>
-              <a:rPr lang="es-MX" sz="1600" dirty="0" err="1">
-                <a:latin typeface="Times New Roman" panose="02020603050405020304" pitchFamily="18" charset="0"/>
-                <a:cs typeface="Times New Roman" panose="02020603050405020304" pitchFamily="18" charset="0"/>
-              </a:rPr>
-              <a:t>Acc</a:t>
-            </a:r>
-            <a:r>
-              <a:rPr lang="es-MX" sz="1600" dirty="0">
-                <a:latin typeface="Times New Roman" panose="02020603050405020304" pitchFamily="18" charset="0"/>
-                <a:cs typeface="Times New Roman" panose="02020603050405020304" pitchFamily="18" charset="0"/>
-              </a:rPr>
-              <a:t>%</a:t>
-            </a:r>
-            <a:br>
-              <a:rPr lang="es-MX" sz="1600" dirty="0">
-                <a:latin typeface="Times New Roman" panose="02020603050405020304" pitchFamily="18" charset="0"/>
-                <a:cs typeface="Times New Roman" panose="02020603050405020304" pitchFamily="18" charset="0"/>
-              </a:rPr>
-            </a:br>
-            <a:r>
-              <a:rPr lang="es-MX" sz="1600" dirty="0" err="1">
-                <a:latin typeface="Times New Roman" panose="02020603050405020304" pitchFamily="18" charset="0"/>
-                <a:cs typeface="Times New Roman" panose="02020603050405020304" pitchFamily="18" charset="0"/>
-              </a:rPr>
-              <a:t>Acc</a:t>
-            </a:r>
-            <a:r>
-              <a:rPr lang="es-MX" sz="1600" dirty="0">
-                <a:latin typeface="Times New Roman" panose="02020603050405020304" pitchFamily="18" charset="0"/>
-                <a:cs typeface="Times New Roman" panose="02020603050405020304" pitchFamily="18" charset="0"/>
-              </a:rPr>
-              <a:t>%</a:t>
-            </a:r>
-            <a:br>
-              <a:rPr lang="es-MX" sz="1600" dirty="0">
-                <a:latin typeface="Times New Roman" panose="02020603050405020304" pitchFamily="18" charset="0"/>
-                <a:cs typeface="Times New Roman" panose="02020603050405020304" pitchFamily="18" charset="0"/>
-              </a:rPr>
-            </a:br>
-            <a:r>
-              <a:rPr lang="es-MX" sz="1600" dirty="0" err="1">
-                <a:latin typeface="Times New Roman" panose="02020603050405020304" pitchFamily="18" charset="0"/>
-                <a:cs typeface="Times New Roman" panose="02020603050405020304" pitchFamily="18" charset="0"/>
-              </a:rPr>
-              <a:t>Acc</a:t>
-            </a:r>
-            <a:r>
-              <a:rPr lang="es-MX" sz="1600" dirty="0">
-                <a:latin typeface="Times New Roman" panose="02020603050405020304" pitchFamily="18" charset="0"/>
-                <a:cs typeface="Times New Roman" panose="02020603050405020304" pitchFamily="18" charset="0"/>
-              </a:rPr>
-              <a:t>%</a:t>
-            </a:r>
-          </a:p>
-        </p:txBody>
-      </p:sp>
-      <p:sp>
-        <p:nvSpPr>
           <p:cNvPr id="56" name="Rectángulo 55">
             <a:extLst>
               <a:ext uri="{FF2B5EF4-FFF2-40B4-BE49-F238E27FC236}">
@@ -38605,8 +38858,8 @@
         </p:nvSpPr>
         <p:spPr>
           <a:xfrm>
-            <a:off x="4013588" y="570628"/>
-            <a:ext cx="2403725" cy="1195348"/>
+            <a:off x="3720813" y="570628"/>
+            <a:ext cx="2703501" cy="1195348"/>
           </a:xfrm>
           <a:prstGeom prst="rect">
             <a:avLst/>
@@ -38657,7 +38910,7 @@
         </p:nvSpPr>
         <p:spPr>
           <a:xfrm>
-            <a:off x="3462710" y="570628"/>
+            <a:off x="3111874" y="615629"/>
             <a:ext cx="516241" cy="1125011"/>
           </a:xfrm>
           <a:prstGeom prst="curvedRightArrow">
@@ -38710,7 +38963,7 @@
         </p:nvSpPr>
         <p:spPr>
           <a:xfrm rot="10800000">
-            <a:off x="6493444" y="563746"/>
+            <a:off x="6609769" y="533398"/>
             <a:ext cx="516241" cy="1125011"/>
           </a:xfrm>
           <a:prstGeom prst="curvedRightArrow">
@@ -38763,8 +39016,8 @@
         </p:nvSpPr>
         <p:spPr>
           <a:xfrm>
-            <a:off x="3931249" y="182066"/>
-            <a:ext cx="2763630" cy="369332"/>
+            <a:off x="3026456" y="4266"/>
+            <a:ext cx="3902973" cy="646331"/>
           </a:xfrm>
           <a:prstGeom prst="rect">
             <a:avLst/>
@@ -38777,27 +39030,14 @@
           </a:bodyPr>
           <a:lstStyle/>
           <a:p>
+            <a:pPr algn="ctr"/>
             <a:r>
-              <a:rPr lang="es-MX" b="0" i="0" dirty="0">
-                <a:solidFill>
-                  <a:srgbClr val="292929"/>
-                </a:solidFill>
-                <a:effectLst/>
-                <a:latin typeface="Roboto" panose="020F0502020204030204" pitchFamily="2" charset="0"/>
+              <a:rPr lang="es-MX" dirty="0">
+                <a:latin typeface="Times New Roman" panose="02020603050405020304" pitchFamily="18" charset="0"/>
+                <a:cs typeface="Times New Roman" panose="02020603050405020304" pitchFamily="18" charset="0"/>
               </a:rPr>
-              <a:t>recombine and </a:t>
+              <a:t>Seleccionar, recombinar, expandir y evaluar</a:t>
             </a:r>
-            <a:r>
-              <a:rPr lang="es-MX" b="0" i="0" dirty="0" err="1">
-                <a:solidFill>
-                  <a:srgbClr val="292929"/>
-                </a:solidFill>
-                <a:effectLst/>
-                <a:latin typeface="Roboto" panose="020F0502020204030204" pitchFamily="2" charset="0"/>
-              </a:rPr>
-              <a:t>evaluate</a:t>
-            </a:r>
-            <a:endParaRPr lang="es-MX" dirty="0"/>
           </a:p>
         </p:txBody>
       </p:sp>
@@ -38817,8 +39057,8 @@
         </p:nvCxnSpPr>
         <p:spPr>
           <a:xfrm>
-            <a:off x="5313064" y="1846833"/>
-            <a:ext cx="0" cy="839363"/>
+            <a:off x="5141614" y="1846833"/>
+            <a:ext cx="0" cy="407417"/>
           </a:xfrm>
           <a:prstGeom prst="straightConnector1">
             <a:avLst/>
@@ -38854,10 +39094,16 @@
           <p:cNvGraphicFramePr>
             <a:graphicFrameLocks noGrp="1"/>
           </p:cNvGraphicFramePr>
-          <p:nvPr/>
+          <p:nvPr>
+            <p:extLst>
+              <p:ext uri="{D42A27DB-BD31-4B8C-83A1-F6EECF244321}">
+                <p14:modId xmlns:p14="http://schemas.microsoft.com/office/powerpoint/2010/main" val="1362265276"/>
+              </p:ext>
+            </p:extLst>
+          </p:nvPr>
         </p:nvGraphicFramePr>
         <p:xfrm>
-          <a:off x="4589164" y="2903725"/>
+          <a:off x="4407035" y="3061541"/>
           <a:ext cx="1447800" cy="196850"/>
         </p:xfrm>
         <a:graphic>
@@ -38911,7 +39157,7 @@
                         <a:buNone/>
                       </a:pPr>
                       <a:r>
-                        <a:rPr lang="es-MX" sz="1100" b="0" i="0" u="none" strike="noStrike">
+                        <a:rPr lang="es-MX" sz="1100" b="0" i="0" u="none" strike="noStrike" dirty="0">
                           <a:solidFill>
                             <a:srgbClr val="83E28E"/>
                           </a:solidFill>
@@ -39097,7 +39343,7 @@
                         <a:buNone/>
                       </a:pPr>
                       <a:r>
-                        <a:rPr lang="es-MX" sz="1100" b="0" i="0" u="none" strike="noStrike">
+                        <a:rPr lang="es-MX" sz="1100" b="0" i="0" u="none" strike="noStrike" dirty="0">
                           <a:solidFill>
                             <a:srgbClr val="000000"/>
                           </a:solidFill>
@@ -39236,7 +39482,7 @@
         </p:nvSpPr>
         <p:spPr>
           <a:xfrm>
-            <a:off x="4120333" y="2566599"/>
+            <a:off x="3938588" y="2267208"/>
             <a:ext cx="2425018" cy="369332"/>
           </a:xfrm>
           <a:prstGeom prst="rect">
@@ -39252,30 +39498,12 @@
           <a:p>
             <a:pPr algn="ctr"/>
             <a:r>
-              <a:rPr lang="es-MX" dirty="0" err="1">
-                <a:latin typeface="Times New Roman" panose="02020603050405020304" pitchFamily="18" charset="0"/>
-                <a:cs typeface="Times New Roman" panose="02020603050405020304" pitchFamily="18" charset="0"/>
-              </a:rPr>
-              <a:t>Resulting</a:t>
-            </a:r>
-            <a:r>
               <a:rPr lang="es-MX" dirty="0">
                 <a:latin typeface="Times New Roman" panose="02020603050405020304" pitchFamily="18" charset="0"/>
                 <a:cs typeface="Times New Roman" panose="02020603050405020304" pitchFamily="18" charset="0"/>
               </a:rPr>
-              <a:t> </a:t>
+              <a:t>Subconjunto resultante</a:t>
             </a:r>
-            <a:r>
-              <a:rPr lang="es-MX" dirty="0" err="1">
-                <a:latin typeface="Times New Roman" panose="02020603050405020304" pitchFamily="18" charset="0"/>
-                <a:cs typeface="Times New Roman" panose="02020603050405020304" pitchFamily="18" charset="0"/>
-              </a:rPr>
-              <a:t>subset</a:t>
-            </a:r>
-            <a:endParaRPr lang="es-MX" dirty="0">
-              <a:latin typeface="Times New Roman" panose="02020603050405020304" pitchFamily="18" charset="0"/>
-              <a:cs typeface="Times New Roman" panose="02020603050405020304" pitchFamily="18" charset="0"/>
-            </a:endParaRPr>
           </a:p>
         </p:txBody>
       </p:sp>
@@ -39294,9 +39522,9 @@
           <p:nvPr/>
         </p:nvCxnSpPr>
         <p:spPr>
-          <a:xfrm>
-            <a:off x="5299102" y="3176244"/>
-            <a:ext cx="0" cy="491566"/>
+          <a:xfrm flipH="1">
+            <a:off x="5141614" y="2617490"/>
+            <a:ext cx="9483" cy="362375"/>
           </a:xfrm>
           <a:prstGeom prst="straightConnector1">
             <a:avLst/>
@@ -39338,7 +39566,7 @@
           <a:blip>
             <a:extLst>
               <a:ext uri="{96DAC541-7B7A-43D3-8B79-37D633B846F1}">
-                <asvg:svgBlip xmlns:asvg="http://schemas.microsoft.com/office/drawing/2016/SVG/main" r:embed="rId4"/>
+                <asvg:svgBlip xmlns:asvg="http://schemas.microsoft.com/office/drawing/2016/SVG/main" r:embed="rId5"/>
               </a:ext>
             </a:extLst>
           </a:blip>
@@ -39348,7 +39576,7 @@
         </p:blipFill>
         <p:spPr>
           <a:xfrm>
-            <a:off x="5040108" y="3996742"/>
+            <a:off x="4938508" y="3996742"/>
             <a:ext cx="517987" cy="517987"/>
           </a:xfrm>
           <a:prstGeom prst="rect">
@@ -39370,7 +39598,7 @@
         </p:nvSpPr>
         <p:spPr>
           <a:xfrm>
-            <a:off x="4120333" y="3622986"/>
+            <a:off x="3973329" y="3603993"/>
             <a:ext cx="2425018" cy="369332"/>
           </a:xfrm>
           <a:prstGeom prst="rect">
@@ -39390,19 +39618,8 @@
                 <a:latin typeface="Times New Roman" panose="02020603050405020304" pitchFamily="18" charset="0"/>
                 <a:cs typeface="Times New Roman" panose="02020603050405020304" pitchFamily="18" charset="0"/>
               </a:rPr>
-              <a:t>Trim </a:t>
+              <a:t>Datos seleccionados</a:t>
             </a:r>
-            <a:r>
-              <a:rPr lang="es-MX" dirty="0" err="1">
-                <a:latin typeface="Times New Roman" panose="02020603050405020304" pitchFamily="18" charset="0"/>
-                <a:cs typeface="Times New Roman" panose="02020603050405020304" pitchFamily="18" charset="0"/>
-              </a:rPr>
-              <a:t>Dataset</a:t>
-            </a:r>
-            <a:endParaRPr lang="es-MX" dirty="0">
-              <a:latin typeface="Times New Roman" panose="02020603050405020304" pitchFamily="18" charset="0"/>
-              <a:cs typeface="Times New Roman" panose="02020603050405020304" pitchFamily="18" charset="0"/>
-            </a:endParaRPr>
           </a:p>
         </p:txBody>
       </p:sp>
@@ -39422,7 +39639,7 @@
         </p:nvCxnSpPr>
         <p:spPr>
           <a:xfrm>
-            <a:off x="5299101" y="4591348"/>
+            <a:off x="5197501" y="4591348"/>
             <a:ext cx="0" cy="491566"/>
           </a:xfrm>
           <a:prstGeom prst="straightConnector1">
@@ -39461,7 +39678,7 @@
         </p:nvGrpSpPr>
         <p:grpSpPr>
           <a:xfrm>
-            <a:off x="7020294" y="1027827"/>
+            <a:off x="6651994" y="1084977"/>
             <a:ext cx="1151722" cy="4612135"/>
             <a:chOff x="2840921" y="760837"/>
             <a:chExt cx="1340190" cy="4612135"/>
@@ -39595,8 +39812,8 @@
         </p:nvSpPr>
         <p:spPr>
           <a:xfrm>
-            <a:off x="8758713" y="381496"/>
-            <a:ext cx="977221" cy="646331"/>
+            <a:off x="8413923" y="241796"/>
+            <a:ext cx="1768492" cy="923330"/>
           </a:xfrm>
           <a:prstGeom prst="rect">
             <a:avLst/>
@@ -39615,21 +39832,7 @@
                 <a:latin typeface="Times New Roman" panose="02020603050405020304" pitchFamily="18" charset="0"/>
                 <a:cs typeface="Times New Roman" panose="02020603050405020304" pitchFamily="18" charset="0"/>
               </a:rPr>
-              <a:t>Start </a:t>
-            </a:r>
-            <a:r>
-              <a:rPr lang="es-MX" dirty="0" err="1">
-                <a:latin typeface="Times New Roman" panose="02020603050405020304" pitchFamily="18" charset="0"/>
-                <a:cs typeface="Times New Roman" panose="02020603050405020304" pitchFamily="18" charset="0"/>
-              </a:rPr>
-              <a:t>Phase</a:t>
-            </a:r>
-            <a:r>
-              <a:rPr lang="es-MX" dirty="0">
-                <a:latin typeface="Times New Roman" panose="02020603050405020304" pitchFamily="18" charset="0"/>
-                <a:cs typeface="Times New Roman" panose="02020603050405020304" pitchFamily="18" charset="0"/>
-              </a:rPr>
-              <a:t> 2</a:t>
+              <a:t>Fase 2 Filtrado del espacio expandido</a:t>
             </a:r>
           </a:p>
         </p:txBody>
@@ -42440,92 +42643,6 @@
           </a:graphicData>
         </a:graphic>
       </p:graphicFrame>
-      <p:sp>
-        <p:nvSpPr>
-          <p:cNvPr id="90" name="CuadroTexto 89">
-            <a:extLst>
-              <a:ext uri="{FF2B5EF4-FFF2-40B4-BE49-F238E27FC236}">
-                <a16:creationId xmlns:a16="http://schemas.microsoft.com/office/drawing/2014/main" id="{CE0FD9B5-5BE3-076B-16F7-AFB78E78C2BC}"/>
-              </a:ext>
-            </a:extLst>
-          </p:cNvPr>
-          <p:cNvSpPr txBox="1"/>
-          <p:nvPr/>
-        </p:nvSpPr>
-        <p:spPr>
-          <a:xfrm>
-            <a:off x="9987708" y="2655379"/>
-            <a:ext cx="977221" cy="830997"/>
-          </a:xfrm>
-          <a:prstGeom prst="rect">
-            <a:avLst/>
-          </a:prstGeom>
-          <a:noFill/>
-        </p:spPr>
-        <p:txBody>
-          <a:bodyPr wrap="square" rtlCol="0">
-            <a:spAutoFit/>
-          </a:bodyPr>
-          <a:lstStyle/>
-          <a:p>
-            <a:pPr algn="ctr"/>
-            <a:r>
-              <a:rPr lang="es-MX" sz="1600" dirty="0" err="1">
-                <a:latin typeface="Times New Roman" panose="02020603050405020304" pitchFamily="18" charset="0"/>
-                <a:cs typeface="Times New Roman" panose="02020603050405020304" pitchFamily="18" charset="0"/>
-              </a:rPr>
-              <a:t>Acc</a:t>
-            </a:r>
-            <a:r>
-              <a:rPr lang="es-MX" sz="1600" dirty="0">
-                <a:latin typeface="Times New Roman" panose="02020603050405020304" pitchFamily="18" charset="0"/>
-                <a:cs typeface="Times New Roman" panose="02020603050405020304" pitchFamily="18" charset="0"/>
-              </a:rPr>
-              <a:t>%</a:t>
-            </a:r>
-            <a:br>
-              <a:rPr lang="es-MX" sz="1600" dirty="0">
-                <a:latin typeface="Times New Roman" panose="02020603050405020304" pitchFamily="18" charset="0"/>
-                <a:cs typeface="Times New Roman" panose="02020603050405020304" pitchFamily="18" charset="0"/>
-              </a:rPr>
-            </a:br>
-            <a:r>
-              <a:rPr lang="es-MX" sz="1600" dirty="0" err="1">
-                <a:latin typeface="Times New Roman" panose="02020603050405020304" pitchFamily="18" charset="0"/>
-                <a:cs typeface="Times New Roman" panose="02020603050405020304" pitchFamily="18" charset="0"/>
-              </a:rPr>
-              <a:t>Acc</a:t>
-            </a:r>
-            <a:r>
-              <a:rPr lang="es-MX" sz="1600" dirty="0">
-                <a:latin typeface="Times New Roman" panose="02020603050405020304" pitchFamily="18" charset="0"/>
-                <a:cs typeface="Times New Roman" panose="02020603050405020304" pitchFamily="18" charset="0"/>
-              </a:rPr>
-              <a:t>%</a:t>
-            </a:r>
-            <a:br>
-              <a:rPr lang="es-MX" sz="1600" dirty="0">
-                <a:latin typeface="Times New Roman" panose="02020603050405020304" pitchFamily="18" charset="0"/>
-                <a:cs typeface="Times New Roman" panose="02020603050405020304" pitchFamily="18" charset="0"/>
-              </a:rPr>
-            </a:br>
-            <a:r>
-              <a:rPr lang="es-MX" sz="1600" dirty="0" err="1">
-                <a:latin typeface="Times New Roman" panose="02020603050405020304" pitchFamily="18" charset="0"/>
-                <a:cs typeface="Times New Roman" panose="02020603050405020304" pitchFamily="18" charset="0"/>
-              </a:rPr>
-              <a:t>Acc</a:t>
-            </a:r>
-            <a:r>
-              <a:rPr lang="es-MX" sz="1600" dirty="0">
-                <a:latin typeface="Times New Roman" panose="02020603050405020304" pitchFamily="18" charset="0"/>
-                <a:cs typeface="Times New Roman" panose="02020603050405020304" pitchFamily="18" charset="0"/>
-              </a:rPr>
-              <a:t>%</a:t>
-            </a:r>
-          </a:p>
-        </p:txBody>
-      </p:sp>
       <p:cxnSp>
         <p:nvCxnSpPr>
           <p:cNvPr id="91" name="Conector recto de flecha 90">
@@ -42633,8 +42750,8 @@
         </p:nvSpPr>
         <p:spPr>
           <a:xfrm>
-            <a:off x="8025900" y="3938033"/>
-            <a:ext cx="2763630" cy="369332"/>
+            <a:off x="7352740" y="3938681"/>
+            <a:ext cx="4090549" cy="369332"/>
           </a:xfrm>
           <a:prstGeom prst="rect">
             <a:avLst/>
@@ -42647,27 +42764,14 @@
           </a:bodyPr>
           <a:lstStyle/>
           <a:p>
+            <a:pPr algn="ctr"/>
             <a:r>
-              <a:rPr lang="es-MX" b="0" i="0" dirty="0">
-                <a:solidFill>
-                  <a:srgbClr val="292929"/>
-                </a:solidFill>
-                <a:effectLst/>
-                <a:latin typeface="Roboto" panose="020F0502020204030204" pitchFamily="2" charset="0"/>
+              <a:rPr lang="es-MX" dirty="0">
+                <a:latin typeface="Times New Roman" panose="02020603050405020304" pitchFamily="18" charset="0"/>
+                <a:cs typeface="Times New Roman" panose="02020603050405020304" pitchFamily="18" charset="0"/>
               </a:rPr>
-              <a:t>recombine and </a:t>
+              <a:t>Seleccionar, recombinar y evaluar </a:t>
             </a:r>
-            <a:r>
-              <a:rPr lang="es-MX" b="0" i="0" dirty="0" err="1">
-                <a:solidFill>
-                  <a:srgbClr val="292929"/>
-                </a:solidFill>
-                <a:effectLst/>
-                <a:latin typeface="Roboto" panose="020F0502020204030204" pitchFamily="2" charset="0"/>
-              </a:rPr>
-              <a:t>evaluate</a:t>
-            </a:r>
-            <a:endParaRPr lang="es-MX" dirty="0"/>
           </a:p>
         </p:txBody>
       </p:sp>
@@ -44020,92 +44124,6 @@
       </p:graphicFrame>
       <p:sp>
         <p:nvSpPr>
-          <p:cNvPr id="101" name="CuadroTexto 100">
-            <a:extLst>
-              <a:ext uri="{FF2B5EF4-FFF2-40B4-BE49-F238E27FC236}">
-                <a16:creationId xmlns:a16="http://schemas.microsoft.com/office/drawing/2014/main" id="{B0209605-2ED1-FDE9-BDEE-8B6F77F8889E}"/>
-              </a:ext>
-            </a:extLst>
-          </p:cNvPr>
-          <p:cNvSpPr txBox="1"/>
-          <p:nvPr/>
-        </p:nvSpPr>
-        <p:spPr>
-          <a:xfrm>
-            <a:off x="9894286" y="4421500"/>
-            <a:ext cx="977221" cy="830997"/>
-          </a:xfrm>
-          <a:prstGeom prst="rect">
-            <a:avLst/>
-          </a:prstGeom>
-          <a:noFill/>
-        </p:spPr>
-        <p:txBody>
-          <a:bodyPr wrap="square" rtlCol="0">
-            <a:spAutoFit/>
-          </a:bodyPr>
-          <a:lstStyle/>
-          <a:p>
-            <a:pPr algn="ctr"/>
-            <a:r>
-              <a:rPr lang="es-MX" sz="1600" dirty="0" err="1">
-                <a:latin typeface="Times New Roman" panose="02020603050405020304" pitchFamily="18" charset="0"/>
-                <a:cs typeface="Times New Roman" panose="02020603050405020304" pitchFamily="18" charset="0"/>
-              </a:rPr>
-              <a:t>Acc</a:t>
-            </a:r>
-            <a:r>
-              <a:rPr lang="es-MX" sz="1600" dirty="0">
-                <a:latin typeface="Times New Roman" panose="02020603050405020304" pitchFamily="18" charset="0"/>
-                <a:cs typeface="Times New Roman" panose="02020603050405020304" pitchFamily="18" charset="0"/>
-              </a:rPr>
-              <a:t>%</a:t>
-            </a:r>
-            <a:br>
-              <a:rPr lang="es-MX" sz="1600" dirty="0">
-                <a:latin typeface="Times New Roman" panose="02020603050405020304" pitchFamily="18" charset="0"/>
-                <a:cs typeface="Times New Roman" panose="02020603050405020304" pitchFamily="18" charset="0"/>
-              </a:rPr>
-            </a:br>
-            <a:r>
-              <a:rPr lang="es-MX" sz="1600" dirty="0" err="1">
-                <a:latin typeface="Times New Roman" panose="02020603050405020304" pitchFamily="18" charset="0"/>
-                <a:cs typeface="Times New Roman" panose="02020603050405020304" pitchFamily="18" charset="0"/>
-              </a:rPr>
-              <a:t>Acc</a:t>
-            </a:r>
-            <a:r>
-              <a:rPr lang="es-MX" sz="1600" dirty="0">
-                <a:latin typeface="Times New Roman" panose="02020603050405020304" pitchFamily="18" charset="0"/>
-                <a:cs typeface="Times New Roman" panose="02020603050405020304" pitchFamily="18" charset="0"/>
-              </a:rPr>
-              <a:t>%</a:t>
-            </a:r>
-            <a:br>
-              <a:rPr lang="es-MX" sz="1600" dirty="0">
-                <a:latin typeface="Times New Roman" panose="02020603050405020304" pitchFamily="18" charset="0"/>
-                <a:cs typeface="Times New Roman" panose="02020603050405020304" pitchFamily="18" charset="0"/>
-              </a:rPr>
-            </a:br>
-            <a:r>
-              <a:rPr lang="es-MX" sz="1600" dirty="0" err="1">
-                <a:latin typeface="Times New Roman" panose="02020603050405020304" pitchFamily="18" charset="0"/>
-                <a:cs typeface="Times New Roman" panose="02020603050405020304" pitchFamily="18" charset="0"/>
-              </a:rPr>
-              <a:t>Acc</a:t>
-            </a:r>
-            <a:r>
-              <a:rPr lang="es-MX" sz="1600" dirty="0">
-                <a:latin typeface="Times New Roman" panose="02020603050405020304" pitchFamily="18" charset="0"/>
-                <a:cs typeface="Times New Roman" panose="02020603050405020304" pitchFamily="18" charset="0"/>
-              </a:rPr>
-              <a:t>%</a:t>
-            </a:r>
-          </a:p>
-        </p:txBody>
-      </p:sp>
-      <p:sp>
-        <p:nvSpPr>
           <p:cNvPr id="102" name="Flecha: curvada hacia la derecha 101">
             <a:extLst>
               <a:ext uri="{FF2B5EF4-FFF2-40B4-BE49-F238E27FC236}">
@@ -44118,8 +44136,8 @@
         </p:nvSpPr>
         <p:spPr>
           <a:xfrm>
-            <a:off x="7693555" y="4274492"/>
-            <a:ext cx="331608" cy="1125011"/>
+            <a:off x="7453958" y="4311461"/>
+            <a:ext cx="438274" cy="1125011"/>
           </a:xfrm>
           <a:prstGeom prst="curvedRightArrow">
             <a:avLst/>
@@ -44171,8 +44189,8 @@
         </p:nvSpPr>
         <p:spPr>
           <a:xfrm rot="10800000">
-            <a:off x="10789530" y="4263326"/>
-            <a:ext cx="369758" cy="1125011"/>
+            <a:off x="10802229" y="4263325"/>
+            <a:ext cx="488069" cy="1125011"/>
           </a:xfrm>
           <a:prstGeom prst="curvedRightArrow">
             <a:avLst/>
@@ -44263,10 +44281,16 @@
           <p:cNvGraphicFramePr>
             <a:graphicFrameLocks noGrp="1"/>
           </p:cNvGraphicFramePr>
-          <p:nvPr/>
+          <p:nvPr>
+            <p:extLst>
+              <p:ext uri="{D42A27DB-BD31-4B8C-83A1-F6EECF244321}">
+                <p14:modId xmlns:p14="http://schemas.microsoft.com/office/powerpoint/2010/main" val="52371720"/>
+              </p:ext>
+            </p:extLst>
+          </p:nvPr>
         </p:nvGraphicFramePr>
         <p:xfrm>
-          <a:off x="8569515" y="6091691"/>
+          <a:off x="8569515" y="6104391"/>
           <a:ext cx="1676400" cy="196850"/>
         </p:xfrm>
         <a:graphic>
@@ -44575,7 +44599,7 @@
                         <a:buNone/>
                       </a:pPr>
                       <a:r>
-                        <a:rPr lang="es-MX" sz="1100" b="0" i="0" u="none" strike="noStrike">
+                        <a:rPr lang="es-MX" sz="1100" b="0" i="0" u="none" strike="noStrike" dirty="0">
                           <a:solidFill>
                             <a:srgbClr val="000000"/>
                           </a:solidFill>
@@ -44730,30 +44754,384 @@
           <a:p>
             <a:pPr algn="ctr"/>
             <a:r>
-              <a:rPr lang="es-MX" dirty="0" err="1">
-                <a:latin typeface="Times New Roman" panose="02020603050405020304" pitchFamily="18" charset="0"/>
-                <a:cs typeface="Times New Roman" panose="02020603050405020304" pitchFamily="18" charset="0"/>
-              </a:rPr>
-              <a:t>Resulting</a:t>
-            </a:r>
-            <a:r>
               <a:rPr lang="es-MX" dirty="0">
                 <a:latin typeface="Times New Roman" panose="02020603050405020304" pitchFamily="18" charset="0"/>
                 <a:cs typeface="Times New Roman" panose="02020603050405020304" pitchFamily="18" charset="0"/>
               </a:rPr>
-              <a:t> </a:t>
+              <a:t>Subconjunto resultante</a:t>
+            </a:r>
+          </a:p>
+        </p:txBody>
+      </p:sp>
+      <p:sp>
+        <p:nvSpPr>
+          <p:cNvPr id="3" name="CuadroTexto 2">
+            <a:extLst>
+              <a:ext uri="{FF2B5EF4-FFF2-40B4-BE49-F238E27FC236}">
+                <a16:creationId xmlns:a16="http://schemas.microsoft.com/office/drawing/2014/main" id="{206FCB3A-392B-61CF-BEB0-6D22305E5982}"/>
+              </a:ext>
+            </a:extLst>
+          </p:cNvPr>
+          <p:cNvSpPr txBox="1"/>
+          <p:nvPr/>
+        </p:nvSpPr>
+        <p:spPr>
+          <a:xfrm>
+            <a:off x="3511411" y="648228"/>
+            <a:ext cx="2425018" cy="1200329"/>
+          </a:xfrm>
+          <a:prstGeom prst="rect">
+            <a:avLst/>
+          </a:prstGeom>
+          <a:noFill/>
+        </p:spPr>
+        <p:txBody>
+          <a:bodyPr wrap="square" rtlCol="0">
+            <a:spAutoFit/>
+          </a:bodyPr>
+          <a:lstStyle/>
+          <a:p>
+            <a:pPr algn="ctr"/>
+            <a:r>
+              <a:rPr lang="el-GR" dirty="0"/>
+              <a:t>Φ</a:t>
             </a:r>
             <a:r>
-              <a:rPr lang="es-MX" dirty="0" err="1">
-                <a:latin typeface="Times New Roman" panose="02020603050405020304" pitchFamily="18" charset="0"/>
-                <a:cs typeface="Times New Roman" panose="02020603050405020304" pitchFamily="18" charset="0"/>
-              </a:rPr>
-              <a:t>subset</a:t>
+              <a:rPr lang="es-MX" dirty="0"/>
+              <a:t>(                             ) </a:t>
+            </a:r>
+          </a:p>
+          <a:p>
+            <a:pPr algn="ctr"/>
+            <a:r>
+              <a:rPr lang="el-GR" dirty="0"/>
+              <a:t>Φ</a:t>
+            </a:r>
+            <a:r>
+              <a:rPr lang="es-MX" dirty="0"/>
+              <a:t>(                             ) </a:t>
             </a:r>
             <a:endParaRPr lang="es-MX" dirty="0">
               <a:latin typeface="Times New Roman" panose="02020603050405020304" pitchFamily="18" charset="0"/>
               <a:cs typeface="Times New Roman" panose="02020603050405020304" pitchFamily="18" charset="0"/>
             </a:endParaRPr>
+          </a:p>
+          <a:p>
+            <a:pPr algn="ctr"/>
+            <a:r>
+              <a:rPr lang="el-GR" dirty="0"/>
+              <a:t>Φ</a:t>
+            </a:r>
+            <a:r>
+              <a:rPr lang="es-MX" dirty="0"/>
+              <a:t>(                             ) </a:t>
+            </a:r>
+            <a:endParaRPr lang="es-MX" dirty="0">
+              <a:latin typeface="Times New Roman" panose="02020603050405020304" pitchFamily="18" charset="0"/>
+              <a:cs typeface="Times New Roman" panose="02020603050405020304" pitchFamily="18" charset="0"/>
+            </a:endParaRPr>
+          </a:p>
+          <a:p>
+            <a:pPr algn="ctr"/>
+            <a:endParaRPr lang="es-MX" dirty="0">
+              <a:latin typeface="Times New Roman" panose="02020603050405020304" pitchFamily="18" charset="0"/>
+              <a:cs typeface="Times New Roman" panose="02020603050405020304" pitchFamily="18" charset="0"/>
+            </a:endParaRPr>
+          </a:p>
+        </p:txBody>
+      </p:sp>
+      <p:sp>
+        <p:nvSpPr>
+          <p:cNvPr id="12" name="CuadroTexto 11">
+            <a:extLst>
+              <a:ext uri="{FF2B5EF4-FFF2-40B4-BE49-F238E27FC236}">
+                <a16:creationId xmlns:a16="http://schemas.microsoft.com/office/drawing/2014/main" id="{EE8D20F4-4523-03AC-92C7-C4CEBBD72FBA}"/>
+              </a:ext>
+            </a:extLst>
+          </p:cNvPr>
+          <p:cNvSpPr txBox="1"/>
+          <p:nvPr/>
+        </p:nvSpPr>
+        <p:spPr>
+          <a:xfrm>
+            <a:off x="5196943" y="691143"/>
+            <a:ext cx="1493290" cy="830997"/>
+          </a:xfrm>
+          <a:prstGeom prst="rect">
+            <a:avLst/>
+          </a:prstGeom>
+          <a:noFill/>
+        </p:spPr>
+        <p:txBody>
+          <a:bodyPr wrap="square" rtlCol="0">
+            <a:spAutoFit/>
+          </a:bodyPr>
+          <a:lstStyle/>
+          <a:p>
+            <a:pPr algn="ctr"/>
+            <a:r>
+              <a:rPr lang="es-MX" sz="1600" dirty="0">
+                <a:latin typeface="Times New Roman" panose="02020603050405020304" pitchFamily="18" charset="0"/>
+                <a:cs typeface="Times New Roman" panose="02020603050405020304" pitchFamily="18" charset="0"/>
+              </a:rPr>
+              <a:t>Fit1(%)</a:t>
+            </a:r>
+          </a:p>
+          <a:p>
+            <a:pPr algn="ctr"/>
+            <a:r>
+              <a:rPr lang="es-MX" sz="1600" dirty="0">
+                <a:latin typeface="Times New Roman" panose="02020603050405020304" pitchFamily="18" charset="0"/>
+                <a:cs typeface="Times New Roman" panose="02020603050405020304" pitchFamily="18" charset="0"/>
+              </a:rPr>
+              <a:t>Fit1(%)</a:t>
+            </a:r>
+          </a:p>
+          <a:p>
+            <a:pPr algn="ctr"/>
+            <a:r>
+              <a:rPr lang="es-MX" sz="1600" dirty="0">
+                <a:latin typeface="Times New Roman" panose="02020603050405020304" pitchFamily="18" charset="0"/>
+                <a:cs typeface="Times New Roman" panose="02020603050405020304" pitchFamily="18" charset="0"/>
+              </a:rPr>
+              <a:t>Fit1(%)</a:t>
+            </a:r>
+          </a:p>
+        </p:txBody>
+      </p:sp>
+      <p:cxnSp>
+        <p:nvCxnSpPr>
+          <p:cNvPr id="18" name="Conector recto de flecha 17">
+            <a:extLst>
+              <a:ext uri="{FF2B5EF4-FFF2-40B4-BE49-F238E27FC236}">
+                <a16:creationId xmlns:a16="http://schemas.microsoft.com/office/drawing/2014/main" id="{68E16C67-7015-7968-3413-9FE625945C38}"/>
+              </a:ext>
+            </a:extLst>
+          </p:cNvPr>
+          <p:cNvCxnSpPr>
+            <a:cxnSpLocks/>
+          </p:cNvCxnSpPr>
+          <p:nvPr/>
+        </p:nvCxnSpPr>
+        <p:spPr>
+          <a:xfrm flipH="1">
+            <a:off x="5147964" y="3315990"/>
+            <a:ext cx="9483" cy="362375"/>
+          </a:xfrm>
+          <a:prstGeom prst="straightConnector1">
+            <a:avLst/>
+          </a:prstGeom>
+          <a:ln>
+            <a:tailEnd type="triangle"/>
+          </a:ln>
+        </p:spPr>
+        <p:style>
+          <a:lnRef idx="3">
+            <a:schemeClr val="dk1"/>
+          </a:lnRef>
+          <a:fillRef idx="0">
+            <a:schemeClr val="dk1"/>
+          </a:fillRef>
+          <a:effectRef idx="2">
+            <a:schemeClr val="dk1"/>
+          </a:effectRef>
+          <a:fontRef idx="minor">
+            <a:schemeClr val="tx1"/>
+          </a:fontRef>
+        </p:style>
+      </p:cxnSp>
+      <p:sp>
+        <p:nvSpPr>
+          <p:cNvPr id="19" name="CuadroTexto 18">
+            <a:extLst>
+              <a:ext uri="{FF2B5EF4-FFF2-40B4-BE49-F238E27FC236}">
+                <a16:creationId xmlns:a16="http://schemas.microsoft.com/office/drawing/2014/main" id="{34B6669D-CE23-E559-5A16-E381646BD10A}"/>
+              </a:ext>
+            </a:extLst>
+          </p:cNvPr>
+          <p:cNvSpPr txBox="1"/>
+          <p:nvPr/>
+        </p:nvSpPr>
+        <p:spPr>
+          <a:xfrm>
+            <a:off x="46407" y="4899447"/>
+            <a:ext cx="2425018" cy="1200329"/>
+          </a:xfrm>
+          <a:prstGeom prst="rect">
+            <a:avLst/>
+          </a:prstGeom>
+          <a:noFill/>
+        </p:spPr>
+        <p:txBody>
+          <a:bodyPr wrap="square" rtlCol="0">
+            <a:spAutoFit/>
+          </a:bodyPr>
+          <a:lstStyle/>
+          <a:p>
+            <a:pPr algn="ctr"/>
+            <a:r>
+              <a:rPr lang="el-GR" dirty="0"/>
+              <a:t>Φ</a:t>
+            </a:r>
+            <a:r>
+              <a:rPr lang="es-MX" dirty="0"/>
+              <a:t>(                             ) </a:t>
+            </a:r>
+          </a:p>
+          <a:p>
+            <a:pPr algn="ctr"/>
+            <a:r>
+              <a:rPr lang="el-GR" dirty="0"/>
+              <a:t>Φ</a:t>
+            </a:r>
+            <a:r>
+              <a:rPr lang="es-MX" dirty="0"/>
+              <a:t>(                             ) </a:t>
+            </a:r>
+            <a:endParaRPr lang="es-MX" dirty="0">
+              <a:latin typeface="Times New Roman" panose="02020603050405020304" pitchFamily="18" charset="0"/>
+              <a:cs typeface="Times New Roman" panose="02020603050405020304" pitchFamily="18" charset="0"/>
+            </a:endParaRPr>
+          </a:p>
+          <a:p>
+            <a:pPr algn="ctr"/>
+            <a:r>
+              <a:rPr lang="el-GR" dirty="0"/>
+              <a:t>Φ</a:t>
+            </a:r>
+            <a:r>
+              <a:rPr lang="es-MX" dirty="0"/>
+              <a:t>(                             ) </a:t>
+            </a:r>
+            <a:endParaRPr lang="es-MX" dirty="0">
+              <a:latin typeface="Times New Roman" panose="02020603050405020304" pitchFamily="18" charset="0"/>
+              <a:cs typeface="Times New Roman" panose="02020603050405020304" pitchFamily="18" charset="0"/>
+            </a:endParaRPr>
+          </a:p>
+          <a:p>
+            <a:pPr algn="ctr"/>
+            <a:endParaRPr lang="es-MX" dirty="0">
+              <a:latin typeface="Times New Roman" panose="02020603050405020304" pitchFamily="18" charset="0"/>
+              <a:cs typeface="Times New Roman" panose="02020603050405020304" pitchFamily="18" charset="0"/>
+            </a:endParaRPr>
+          </a:p>
+        </p:txBody>
+      </p:sp>
+      <p:sp>
+        <p:nvSpPr>
+          <p:cNvPr id="25" name="CuadroTexto 24">
+            <a:extLst>
+              <a:ext uri="{FF2B5EF4-FFF2-40B4-BE49-F238E27FC236}">
+                <a16:creationId xmlns:a16="http://schemas.microsoft.com/office/drawing/2014/main" id="{6FF3EC7F-4EE2-E358-BEE7-D27764EFC42B}"/>
+              </a:ext>
+            </a:extLst>
+          </p:cNvPr>
+          <p:cNvSpPr txBox="1"/>
+          <p:nvPr/>
+        </p:nvSpPr>
+        <p:spPr>
+          <a:xfrm>
+            <a:off x="9282593" y="2686196"/>
+            <a:ext cx="2608666" cy="830997"/>
+          </a:xfrm>
+          <a:prstGeom prst="rect">
+            <a:avLst/>
+          </a:prstGeom>
+          <a:noFill/>
+        </p:spPr>
+        <p:txBody>
+          <a:bodyPr wrap="square" rtlCol="0">
+            <a:spAutoFit/>
+          </a:bodyPr>
+          <a:lstStyle/>
+          <a:p>
+            <a:pPr algn="ctr"/>
+            <a:r>
+              <a:rPr lang="es-MX" sz="1600" dirty="0">
+                <a:latin typeface="Times New Roman" panose="02020603050405020304" pitchFamily="18" charset="0"/>
+                <a:cs typeface="Times New Roman" panose="02020603050405020304" pitchFamily="18" charset="0"/>
+              </a:rPr>
+              <a:t>Fit2(%)</a:t>
+            </a:r>
+          </a:p>
+          <a:p>
+            <a:pPr algn="ctr"/>
+            <a:r>
+              <a:rPr lang="es-MX" sz="1600" dirty="0">
+                <a:latin typeface="Times New Roman" panose="02020603050405020304" pitchFamily="18" charset="0"/>
+                <a:cs typeface="Times New Roman" panose="02020603050405020304" pitchFamily="18" charset="0"/>
+              </a:rPr>
+              <a:t>Fit2(%)</a:t>
+            </a:r>
+          </a:p>
+          <a:p>
+            <a:pPr algn="ctr"/>
+            <a:r>
+              <a:rPr lang="es-MX" sz="1600" dirty="0">
+                <a:latin typeface="Times New Roman" panose="02020603050405020304" pitchFamily="18" charset="0"/>
+                <a:cs typeface="Times New Roman" panose="02020603050405020304" pitchFamily="18" charset="0"/>
+              </a:rPr>
+              <a:t>Fit2(%)</a:t>
+            </a:r>
+          </a:p>
+        </p:txBody>
+      </p:sp>
+      <p:sp>
+        <p:nvSpPr>
+          <p:cNvPr id="26" name="CuadroTexto 25">
+            <a:extLst>
+              <a:ext uri="{FF2B5EF4-FFF2-40B4-BE49-F238E27FC236}">
+                <a16:creationId xmlns:a16="http://schemas.microsoft.com/office/drawing/2014/main" id="{272DFAE6-E464-495B-5658-838702FC3757}"/>
+              </a:ext>
+            </a:extLst>
+          </p:cNvPr>
+          <p:cNvSpPr txBox="1"/>
+          <p:nvPr/>
+        </p:nvSpPr>
+        <p:spPr>
+          <a:xfrm>
+            <a:off x="1755249" y="4937939"/>
+            <a:ext cx="1493290" cy="830997"/>
+          </a:xfrm>
+          <a:prstGeom prst="rect">
+            <a:avLst/>
+          </a:prstGeom>
+          <a:noFill/>
+        </p:spPr>
+        <p:txBody>
+          <a:bodyPr wrap="square" rtlCol="0">
+            <a:spAutoFit/>
+          </a:bodyPr>
+          <a:lstStyle/>
+          <a:p>
+            <a:pPr algn="ctr"/>
+            <a:r>
+              <a:rPr lang="es-MX" sz="1600" dirty="0">
+                <a:latin typeface="Times New Roman" panose="02020603050405020304" pitchFamily="18" charset="0"/>
+                <a:cs typeface="Times New Roman" panose="02020603050405020304" pitchFamily="18" charset="0"/>
+              </a:rPr>
+              <a:t>Fit1(%)</a:t>
+            </a:r>
+          </a:p>
+          <a:p>
+            <a:pPr algn="ctr"/>
+            <a:r>
+              <a:rPr lang="es-MX" sz="1600" dirty="0">
+                <a:latin typeface="Times New Roman" panose="02020603050405020304" pitchFamily="18" charset="0"/>
+                <a:cs typeface="Times New Roman" panose="02020603050405020304" pitchFamily="18" charset="0"/>
+              </a:rPr>
+              <a:t>Fit1(%)</a:t>
+            </a:r>
+          </a:p>
+          <a:p>
+            <a:pPr algn="ctr"/>
+            <a:r>
+              <a:rPr lang="es-MX" sz="1600" dirty="0">
+                <a:latin typeface="Times New Roman" panose="02020603050405020304" pitchFamily="18" charset="0"/>
+                <a:cs typeface="Times New Roman" panose="02020603050405020304" pitchFamily="18" charset="0"/>
+              </a:rPr>
+              <a:t>Fit1(%)</a:t>
+            </a:r>
           </a:p>
         </p:txBody>
       </p:sp>
@@ -45063,4 +45441,319 @@
     </a:ext>
   </a:extLst>
 </a:theme>
+</file>
+
+<file path=ppt/theme/theme2.xml><?xml version="1.0" encoding="utf-8"?>
+<a:theme xmlns:a="http://schemas.openxmlformats.org/drawingml/2006/main" name="Tema de Office">
+  <a:themeElements>
+    <a:clrScheme name="Office">
+      <a:dk1>
+        <a:sysClr val="windowText" lastClr="000000"/>
+      </a:dk1>
+      <a:lt1>
+        <a:sysClr val="window" lastClr="FFFFFF"/>
+      </a:lt1>
+      <a:dk2>
+        <a:srgbClr val="0E2841"/>
+      </a:dk2>
+      <a:lt2>
+        <a:srgbClr val="E8E8E8"/>
+      </a:lt2>
+      <a:accent1>
+        <a:srgbClr val="156082"/>
+      </a:accent1>
+      <a:accent2>
+        <a:srgbClr val="E97132"/>
+      </a:accent2>
+      <a:accent3>
+        <a:srgbClr val="196B24"/>
+      </a:accent3>
+      <a:accent4>
+        <a:srgbClr val="0F9ED5"/>
+      </a:accent4>
+      <a:accent5>
+        <a:srgbClr val="A02B93"/>
+      </a:accent5>
+      <a:accent6>
+        <a:srgbClr val="4EA72E"/>
+      </a:accent6>
+      <a:hlink>
+        <a:srgbClr val="467886"/>
+      </a:hlink>
+      <a:folHlink>
+        <a:srgbClr val="96607D"/>
+      </a:folHlink>
+    </a:clrScheme>
+    <a:fontScheme name="Office">
+      <a:majorFont>
+        <a:latin typeface="Aptos Display" panose="02110004020202020204"/>
+        <a:ea typeface=""/>
+        <a:cs typeface=""/>
+        <a:font script="Jpan" typeface="游ゴシック Light"/>
+        <a:font script="Hang" typeface="맑은 고딕"/>
+        <a:font script="Hans" typeface="等线 Light"/>
+        <a:font script="Hant" typeface="新細明體"/>
+        <a:font script="Arab" typeface="Times New Roman"/>
+        <a:font script="Hebr" typeface="Times New Roman"/>
+        <a:font script="Thai" typeface="Angsana New"/>
+        <a:font script="Ethi" typeface="Nyala"/>
+        <a:font script="Beng" typeface="Vrinda"/>
+        <a:font script="Gujr" typeface="Shruti"/>
+        <a:font script="Khmr" typeface="MoolBoran"/>
+        <a:font script="Knda" typeface="Tunga"/>
+        <a:font script="Guru" typeface="Raavi"/>
+        <a:font script="Cans" typeface="Euphemia"/>
+        <a:font script="Cher" typeface="Plantagenet Cherokee"/>
+        <a:font script="Yiii" typeface="Microsoft Yi Baiti"/>
+        <a:font script="Tibt" typeface="Microsoft Himalaya"/>
+        <a:font script="Thaa" typeface="MV Boli"/>
+        <a:font script="Deva" typeface="Mangal"/>
+        <a:font script="Telu" typeface="Gautami"/>
+        <a:font script="Taml" typeface="Latha"/>
+        <a:font script="Syrc" typeface="Estrangelo Edessa"/>
+        <a:font script="Orya" typeface="Kalinga"/>
+        <a:font script="Mlym" typeface="Kartika"/>
+        <a:font script="Laoo" typeface="DokChampa"/>
+        <a:font script="Sinh" typeface="Iskoola Pota"/>
+        <a:font script="Mong" typeface="Mongolian Baiti"/>
+        <a:font script="Viet" typeface="Times New Roman"/>
+        <a:font script="Uigh" typeface="Microsoft Uighur"/>
+        <a:font script="Geor" typeface="Sylfaen"/>
+        <a:font script="Armn" typeface="Arial"/>
+        <a:font script="Bugi" typeface="Leelawadee UI"/>
+        <a:font script="Bopo" typeface="Microsoft JhengHei"/>
+        <a:font script="Java" typeface="Javanese Text"/>
+        <a:font script="Lisu" typeface="Segoe UI"/>
+        <a:font script="Mymr" typeface="Myanmar Text"/>
+        <a:font script="Nkoo" typeface="Ebrima"/>
+        <a:font script="Olck" typeface="Nirmala UI"/>
+        <a:font script="Osma" typeface="Ebrima"/>
+        <a:font script="Phag" typeface="Phagspa"/>
+        <a:font script="Syrn" typeface="Estrangelo Edessa"/>
+        <a:font script="Syrj" typeface="Estrangelo Edessa"/>
+        <a:font script="Syre" typeface="Estrangelo Edessa"/>
+        <a:font script="Sora" typeface="Nirmala UI"/>
+        <a:font script="Tale" typeface="Microsoft Tai Le"/>
+        <a:font script="Talu" typeface="Microsoft New Tai Lue"/>
+        <a:font script="Tfng" typeface="Ebrima"/>
+      </a:majorFont>
+      <a:minorFont>
+        <a:latin typeface="Aptos" panose="02110004020202020204"/>
+        <a:ea typeface=""/>
+        <a:cs typeface=""/>
+        <a:font script="Jpan" typeface="游ゴシック"/>
+        <a:font script="Hang" typeface="맑은 고딕"/>
+        <a:font script="Hans" typeface="等线"/>
+        <a:font script="Hant" typeface="新細明體"/>
+        <a:font script="Arab" typeface="Arial"/>
+        <a:font script="Hebr" typeface="Arial"/>
+        <a:font script="Thai" typeface="Cordia New"/>
+        <a:font script="Ethi" typeface="Nyala"/>
+        <a:font script="Beng" typeface="Vrinda"/>
+        <a:font script="Gujr" typeface="Shruti"/>
+        <a:font script="Khmr" typeface="DaunPenh"/>
+        <a:font script="Knda" typeface="Tunga"/>
+        <a:font script="Guru" typeface="Raavi"/>
+        <a:font script="Cans" typeface="Euphemia"/>
+        <a:font script="Cher" typeface="Plantagenet Cherokee"/>
+        <a:font script="Yiii" typeface="Microsoft Yi Baiti"/>
+        <a:font script="Tibt" typeface="Microsoft Himalaya"/>
+        <a:font script="Thaa" typeface="MV Boli"/>
+        <a:font script="Deva" typeface="Mangal"/>
+        <a:font script="Telu" typeface="Gautami"/>
+        <a:font script="Taml" typeface="Latha"/>
+        <a:font script="Syrc" typeface="Estrangelo Edessa"/>
+        <a:font script="Orya" typeface="Kalinga"/>
+        <a:font script="Mlym" typeface="Kartika"/>
+        <a:font script="Laoo" typeface="DokChampa"/>
+        <a:font script="Sinh" typeface="Iskoola Pota"/>
+        <a:font script="Mong" typeface="Mongolian Baiti"/>
+        <a:font script="Viet" typeface="Arial"/>
+        <a:font script="Uigh" typeface="Microsoft Uighur"/>
+        <a:font script="Geor" typeface="Sylfaen"/>
+        <a:font script="Armn" typeface="Arial"/>
+        <a:font script="Bugi" typeface="Leelawadee UI"/>
+        <a:font script="Bopo" typeface="Microsoft JhengHei"/>
+        <a:font script="Java" typeface="Javanese Text"/>
+        <a:font script="Lisu" typeface="Segoe UI"/>
+        <a:font script="Mymr" typeface="Myanmar Text"/>
+        <a:font script="Nkoo" typeface="Ebrima"/>
+        <a:font script="Olck" typeface="Nirmala UI"/>
+        <a:font script="Osma" typeface="Ebrima"/>
+        <a:font script="Phag" typeface="Phagspa"/>
+        <a:font script="Syrn" typeface="Estrangelo Edessa"/>
+        <a:font script="Syrj" typeface="Estrangelo Edessa"/>
+        <a:font script="Syre" typeface="Estrangelo Edessa"/>
+        <a:font script="Sora" typeface="Nirmala UI"/>
+        <a:font script="Tale" typeface="Microsoft Tai Le"/>
+        <a:font script="Talu" typeface="Microsoft New Tai Lue"/>
+        <a:font script="Tfng" typeface="Ebrima"/>
+      </a:minorFont>
+    </a:fontScheme>
+    <a:fmtScheme name="Office">
+      <a:fillStyleLst>
+        <a:solidFill>
+          <a:schemeClr val="phClr"/>
+        </a:solidFill>
+        <a:gradFill rotWithShape="1">
+          <a:gsLst>
+            <a:gs pos="0">
+              <a:schemeClr val="phClr">
+                <a:lumMod val="110000"/>
+                <a:satMod val="105000"/>
+                <a:tint val="67000"/>
+              </a:schemeClr>
+            </a:gs>
+            <a:gs pos="50000">
+              <a:schemeClr val="phClr">
+                <a:lumMod val="105000"/>
+                <a:satMod val="103000"/>
+                <a:tint val="73000"/>
+              </a:schemeClr>
+            </a:gs>
+            <a:gs pos="100000">
+              <a:schemeClr val="phClr">
+                <a:lumMod val="105000"/>
+                <a:satMod val="109000"/>
+                <a:tint val="81000"/>
+              </a:schemeClr>
+            </a:gs>
+          </a:gsLst>
+          <a:lin ang="5400000" scaled="0"/>
+        </a:gradFill>
+        <a:gradFill rotWithShape="1">
+          <a:gsLst>
+            <a:gs pos="0">
+              <a:schemeClr val="phClr">
+                <a:satMod val="103000"/>
+                <a:lumMod val="102000"/>
+                <a:tint val="94000"/>
+              </a:schemeClr>
+            </a:gs>
+            <a:gs pos="50000">
+              <a:schemeClr val="phClr">
+                <a:satMod val="110000"/>
+                <a:lumMod val="100000"/>
+                <a:shade val="100000"/>
+              </a:schemeClr>
+            </a:gs>
+            <a:gs pos="100000">
+              <a:schemeClr val="phClr">
+                <a:lumMod val="99000"/>
+                <a:satMod val="120000"/>
+                <a:shade val="78000"/>
+              </a:schemeClr>
+            </a:gs>
+          </a:gsLst>
+          <a:lin ang="5400000" scaled="0"/>
+        </a:gradFill>
+      </a:fillStyleLst>
+      <a:lnStyleLst>
+        <a:ln w="12700" cap="flat" cmpd="sng" algn="ctr">
+          <a:solidFill>
+            <a:schemeClr val="phClr"/>
+          </a:solidFill>
+          <a:prstDash val="solid"/>
+          <a:miter lim="800000"/>
+        </a:ln>
+        <a:ln w="19050" cap="flat" cmpd="sng" algn="ctr">
+          <a:solidFill>
+            <a:schemeClr val="phClr"/>
+          </a:solidFill>
+          <a:prstDash val="solid"/>
+          <a:miter lim="800000"/>
+        </a:ln>
+        <a:ln w="25400" cap="flat" cmpd="sng" algn="ctr">
+          <a:solidFill>
+            <a:schemeClr val="phClr"/>
+          </a:solidFill>
+          <a:prstDash val="solid"/>
+          <a:miter lim="800000"/>
+        </a:ln>
+      </a:lnStyleLst>
+      <a:effectStyleLst>
+        <a:effectStyle>
+          <a:effectLst/>
+        </a:effectStyle>
+        <a:effectStyle>
+          <a:effectLst/>
+        </a:effectStyle>
+        <a:effectStyle>
+          <a:effectLst>
+            <a:outerShdw blurRad="57150" dist="19050" dir="5400000" algn="ctr" rotWithShape="0">
+              <a:srgbClr val="000000">
+                <a:alpha val="63000"/>
+              </a:srgbClr>
+            </a:outerShdw>
+          </a:effectLst>
+        </a:effectStyle>
+      </a:effectStyleLst>
+      <a:bgFillStyleLst>
+        <a:solidFill>
+          <a:schemeClr val="phClr"/>
+        </a:solidFill>
+        <a:solidFill>
+          <a:schemeClr val="phClr">
+            <a:tint val="95000"/>
+            <a:satMod val="170000"/>
+          </a:schemeClr>
+        </a:solidFill>
+        <a:gradFill rotWithShape="1">
+          <a:gsLst>
+            <a:gs pos="0">
+              <a:schemeClr val="phClr">
+                <a:tint val="93000"/>
+                <a:satMod val="150000"/>
+                <a:shade val="98000"/>
+                <a:lumMod val="102000"/>
+              </a:schemeClr>
+            </a:gs>
+            <a:gs pos="50000">
+              <a:schemeClr val="phClr">
+                <a:tint val="98000"/>
+                <a:satMod val="130000"/>
+                <a:shade val="90000"/>
+                <a:lumMod val="103000"/>
+              </a:schemeClr>
+            </a:gs>
+            <a:gs pos="100000">
+              <a:schemeClr val="phClr">
+                <a:shade val="63000"/>
+                <a:satMod val="120000"/>
+              </a:schemeClr>
+            </a:gs>
+          </a:gsLst>
+          <a:lin ang="5400000" scaled="0"/>
+        </a:gradFill>
+      </a:bgFillStyleLst>
+    </a:fmtScheme>
+  </a:themeElements>
+  <a:objectDefaults>
+    <a:lnDef>
+      <a:spPr/>
+      <a:bodyPr/>
+      <a:lstStyle/>
+      <a:style>
+        <a:lnRef idx="2">
+          <a:schemeClr val="accent1"/>
+        </a:lnRef>
+        <a:fillRef idx="0">
+          <a:schemeClr val="accent1"/>
+        </a:fillRef>
+        <a:effectRef idx="1">
+          <a:schemeClr val="accent1"/>
+        </a:effectRef>
+        <a:fontRef idx="minor">
+          <a:schemeClr val="tx1"/>
+        </a:fontRef>
+      </a:style>
+    </a:lnDef>
+  </a:objectDefaults>
+  <a:extraClrSchemeLst/>
+  <a:extLst>
+    <a:ext uri="{05A4C25C-085E-4340-85A3-A5531E510DB2}">
+      <thm15:themeFamily xmlns:thm15="http://schemas.microsoft.com/office/thememl/2012/main" name="Office Theme" id="{2E142A2C-CD16-42D6-873A-C26D2A0506FA}" vid="{1BDDFF52-6CD6-40A5-AB3C-68EB2F1E4D0A}"/>
+    </a:ext>
+  </a:extLst>
+</a:theme>
 </file>
</xml_diff>